<commit_message>
Workshop 2: Clarify embeddings
</commit_message>
<xml_diff>
--- a/workshop-2-tokenization.pptx
+++ b/workshop-2-tokenization.pptx
@@ -7960,6 +7960,395 @@
           </a:p>
         </p:txBody>
       </p:sp>
+      <p:sp>
+        <p:nvSpPr>
+          <p:cNvPr id="7" name="Rectangle 6">
+            <a:extLst>
+              <a:ext uri="{FF2B5EF4-FFF2-40B4-BE49-F238E27FC236}">
+                <a16:creationId xmlns:a16="http://schemas.microsoft.com/office/drawing/2014/main" id="{A1911230-7230-7C91-E8BF-7E5BC0CA21E6}"/>
+              </a:ext>
+            </a:extLst>
+          </p:cNvPr>
+          <p:cNvSpPr/>
+          <p:nvPr/>
+        </p:nvSpPr>
+        <p:spPr>
+          <a:xfrm>
+            <a:off x="8729239" y="2661554"/>
+            <a:ext cx="3047894" cy="1339740"/>
+          </a:xfrm>
+          <a:prstGeom prst="rect">
+            <a:avLst/>
+          </a:prstGeom>
+          <a:solidFill>
+            <a:schemeClr val="accent2"/>
+          </a:solidFill>
+        </p:spPr>
+        <p:style>
+          <a:lnRef idx="2">
+            <a:schemeClr val="accent1">
+              <a:shade val="15000"/>
+            </a:schemeClr>
+          </a:lnRef>
+          <a:fillRef idx="1">
+            <a:schemeClr val="accent1"/>
+          </a:fillRef>
+          <a:effectRef idx="0">
+            <a:schemeClr val="accent1"/>
+          </a:effectRef>
+          <a:fontRef idx="minor">
+            <a:schemeClr val="lt1"/>
+          </a:fontRef>
+        </p:style>
+        <p:txBody>
+          <a:bodyPr rtlCol="0" anchor="ctr"/>
+          <a:lstStyle/>
+          <a:p>
+            <a:pPr algn="ctr"/>
+            <a:r>
+              <a:rPr lang="en-US" dirty="0">
+                <a:solidFill>
+                  <a:schemeClr val="tx1"/>
+                </a:solidFill>
+              </a:rPr>
+              <a:t>Lookup: each row is an embedding vector</a:t>
+            </a:r>
+          </a:p>
+          <a:p>
+            <a:pPr algn="ctr"/>
+            <a:endParaRPr lang="en-US" dirty="0">
+              <a:solidFill>
+                <a:schemeClr val="tx1"/>
+              </a:solidFill>
+            </a:endParaRPr>
+          </a:p>
+          <a:p>
+            <a:pPr algn="ctr"/>
+            <a:r>
+              <a:rPr lang="en-US" dirty="0">
+                <a:solidFill>
+                  <a:schemeClr val="tx1"/>
+                </a:solidFill>
+              </a:rPr>
+              <a:t>“fox” -&gt; ID=2 </a:t>
+            </a:r>
+            <a:br>
+              <a:rPr lang="en-US" dirty="0">
+                <a:solidFill>
+                  <a:schemeClr val="tx1"/>
+                </a:solidFill>
+              </a:rPr>
+            </a:br>
+            <a:r>
+              <a:rPr lang="en-US" dirty="0">
+                <a:solidFill>
+                  <a:schemeClr val="tx1"/>
+                </a:solidFill>
+              </a:rPr>
+              <a:t>-&gt; [1.2753   -0.2010   -0.1606]</a:t>
+            </a:r>
+          </a:p>
+        </p:txBody>
+      </p:sp>
+      <p:sp>
+        <p:nvSpPr>
+          <p:cNvPr id="8" name="Rectangle 7">
+            <a:extLst>
+              <a:ext uri="{FF2B5EF4-FFF2-40B4-BE49-F238E27FC236}">
+                <a16:creationId xmlns:a16="http://schemas.microsoft.com/office/drawing/2014/main" id="{E447AD2B-ACD2-A4CB-8290-131177500787}"/>
+              </a:ext>
+            </a:extLst>
+          </p:cNvPr>
+          <p:cNvSpPr/>
+          <p:nvPr/>
+        </p:nvSpPr>
+        <p:spPr>
+          <a:xfrm>
+            <a:off x="8729239" y="4794842"/>
+            <a:ext cx="3186897" cy="1339740"/>
+          </a:xfrm>
+          <a:prstGeom prst="rect">
+            <a:avLst/>
+          </a:prstGeom>
+          <a:solidFill>
+            <a:schemeClr val="accent2"/>
+          </a:solidFill>
+        </p:spPr>
+        <p:style>
+          <a:lnRef idx="2">
+            <a:schemeClr val="accent1">
+              <a:shade val="15000"/>
+            </a:schemeClr>
+          </a:lnRef>
+          <a:fillRef idx="1">
+            <a:schemeClr val="accent1"/>
+          </a:fillRef>
+          <a:effectRef idx="0">
+            <a:schemeClr val="accent1"/>
+          </a:effectRef>
+          <a:fontRef idx="minor">
+            <a:schemeClr val="lt1"/>
+          </a:fontRef>
+        </p:style>
+        <p:txBody>
+          <a:bodyPr rtlCol="0" anchor="ctr"/>
+          <a:lstStyle/>
+          <a:p>
+            <a:pPr algn="ctr"/>
+            <a:r>
+              <a:rPr lang="en-US" dirty="0">
+                <a:solidFill>
+                  <a:schemeClr val="tx1"/>
+                </a:solidFill>
+              </a:rPr>
+              <a:t>Each row of this tensor is the embedding of each token in the input “fox jumps over dog”</a:t>
+            </a:r>
+          </a:p>
+          <a:p>
+            <a:pPr algn="ctr"/>
+            <a:r>
+              <a:rPr lang="en-US" dirty="0">
+                <a:solidFill>
+                  <a:schemeClr val="tx1"/>
+                </a:solidFill>
+              </a:rPr>
+              <a:t>(token ID [2, 3, 5, 1]) in order</a:t>
+            </a:r>
+          </a:p>
+        </p:txBody>
+      </p:sp>
+      <p:sp>
+        <p:nvSpPr>
+          <p:cNvPr id="9" name="Rectangle 8">
+            <a:extLst>
+              <a:ext uri="{FF2B5EF4-FFF2-40B4-BE49-F238E27FC236}">
+                <a16:creationId xmlns:a16="http://schemas.microsoft.com/office/drawing/2014/main" id="{472E9C30-C8AD-A09F-7BE2-43879819F400}"/>
+              </a:ext>
+            </a:extLst>
+          </p:cNvPr>
+          <p:cNvSpPr/>
+          <p:nvPr/>
+        </p:nvSpPr>
+        <p:spPr>
+          <a:xfrm>
+            <a:off x="6491468" y="2768729"/>
+            <a:ext cx="221849" cy="1320542"/>
+          </a:xfrm>
+          <a:prstGeom prst="rect">
+            <a:avLst/>
+          </a:prstGeom>
+          <a:solidFill>
+            <a:schemeClr val="accent2"/>
+          </a:solidFill>
+        </p:spPr>
+        <p:style>
+          <a:lnRef idx="2">
+            <a:schemeClr val="accent1">
+              <a:shade val="15000"/>
+            </a:schemeClr>
+          </a:lnRef>
+          <a:fillRef idx="1">
+            <a:schemeClr val="accent1"/>
+          </a:fillRef>
+          <a:effectRef idx="0">
+            <a:schemeClr val="accent1"/>
+          </a:effectRef>
+          <a:fontRef idx="minor">
+            <a:schemeClr val="lt1"/>
+          </a:fontRef>
+        </p:style>
+        <p:txBody>
+          <a:bodyPr rtlCol="0" anchor="ctr"/>
+          <a:lstStyle/>
+          <a:p>
+            <a:pPr algn="ctr"/>
+            <a:r>
+              <a:rPr lang="en-US" sz="1400" dirty="0">
+                <a:solidFill>
+                  <a:schemeClr val="tx1"/>
+                </a:solidFill>
+              </a:rPr>
+              <a:t>0</a:t>
+            </a:r>
+            <a:br>
+              <a:rPr lang="en-US" sz="1400" dirty="0">
+                <a:solidFill>
+                  <a:schemeClr val="tx1"/>
+                </a:solidFill>
+              </a:rPr>
+            </a:br>
+            <a:r>
+              <a:rPr lang="en-US" sz="1400" dirty="0">
+                <a:solidFill>
+                  <a:schemeClr val="tx1"/>
+                </a:solidFill>
+              </a:rPr>
+              <a:t>1</a:t>
+            </a:r>
+            <a:br>
+              <a:rPr lang="en-US" sz="1400" dirty="0">
+                <a:solidFill>
+                  <a:schemeClr val="tx1"/>
+                </a:solidFill>
+              </a:rPr>
+            </a:br>
+            <a:r>
+              <a:rPr lang="en-US" sz="1400" dirty="0">
+                <a:solidFill>
+                  <a:schemeClr val="tx1"/>
+                </a:solidFill>
+              </a:rPr>
+              <a:t>2</a:t>
+            </a:r>
+            <a:br>
+              <a:rPr lang="en-US" sz="1400" dirty="0">
+                <a:solidFill>
+                  <a:schemeClr val="tx1"/>
+                </a:solidFill>
+              </a:rPr>
+            </a:br>
+            <a:r>
+              <a:rPr lang="en-US" sz="1400" dirty="0">
+                <a:solidFill>
+                  <a:schemeClr val="tx1"/>
+                </a:solidFill>
+              </a:rPr>
+              <a:t>3</a:t>
+            </a:r>
+            <a:br>
+              <a:rPr lang="en-US" sz="1400" dirty="0">
+                <a:solidFill>
+                  <a:schemeClr val="tx1"/>
+                </a:solidFill>
+              </a:rPr>
+            </a:br>
+            <a:r>
+              <a:rPr lang="en-US" sz="1400" dirty="0">
+                <a:solidFill>
+                  <a:schemeClr val="tx1"/>
+                </a:solidFill>
+              </a:rPr>
+              <a:t>4</a:t>
+            </a:r>
+            <a:br>
+              <a:rPr lang="en-US" sz="1400" dirty="0">
+                <a:solidFill>
+                  <a:schemeClr val="tx1"/>
+                </a:solidFill>
+              </a:rPr>
+            </a:br>
+            <a:r>
+              <a:rPr lang="en-US" sz="1400" dirty="0">
+                <a:solidFill>
+                  <a:schemeClr val="tx1"/>
+                </a:solidFill>
+              </a:rPr>
+              <a:t>5</a:t>
+            </a:r>
+          </a:p>
+        </p:txBody>
+      </p:sp>
+      <p:sp>
+        <p:nvSpPr>
+          <p:cNvPr id="10" name="Rectangle 9">
+            <a:extLst>
+              <a:ext uri="{FF2B5EF4-FFF2-40B4-BE49-F238E27FC236}">
+                <a16:creationId xmlns:a16="http://schemas.microsoft.com/office/drawing/2014/main" id="{FEA8B853-CD35-55AE-0F6F-998BE1EC9E29}"/>
+              </a:ext>
+            </a:extLst>
+          </p:cNvPr>
+          <p:cNvSpPr/>
+          <p:nvPr/>
+        </p:nvSpPr>
+        <p:spPr>
+          <a:xfrm>
+            <a:off x="6491467" y="4876866"/>
+            <a:ext cx="221849" cy="895238"/>
+          </a:xfrm>
+          <a:prstGeom prst="rect">
+            <a:avLst/>
+          </a:prstGeom>
+          <a:solidFill>
+            <a:schemeClr val="accent2"/>
+          </a:solidFill>
+        </p:spPr>
+        <p:style>
+          <a:lnRef idx="2">
+            <a:schemeClr val="accent1">
+              <a:shade val="15000"/>
+            </a:schemeClr>
+          </a:lnRef>
+          <a:fillRef idx="1">
+            <a:schemeClr val="accent1"/>
+          </a:fillRef>
+          <a:effectRef idx="0">
+            <a:schemeClr val="accent1"/>
+          </a:effectRef>
+          <a:fontRef idx="minor">
+            <a:schemeClr val="lt1"/>
+          </a:fontRef>
+        </p:style>
+        <p:txBody>
+          <a:bodyPr rtlCol="0" anchor="ctr"/>
+          <a:lstStyle/>
+          <a:p>
+            <a:pPr algn="ctr"/>
+            <a:r>
+              <a:rPr lang="en-US" sz="1400" dirty="0">
+                <a:solidFill>
+                  <a:schemeClr val="tx1"/>
+                </a:solidFill>
+              </a:rPr>
+              <a:t>2</a:t>
+            </a:r>
+            <a:br>
+              <a:rPr lang="en-US" sz="1400" dirty="0">
+                <a:solidFill>
+                  <a:schemeClr val="tx1"/>
+                </a:solidFill>
+              </a:rPr>
+            </a:br>
+            <a:r>
+              <a:rPr lang="en-US" sz="1400" dirty="0">
+                <a:solidFill>
+                  <a:schemeClr val="tx1"/>
+                </a:solidFill>
+              </a:rPr>
+              <a:t>3</a:t>
+            </a:r>
+            <a:br>
+              <a:rPr lang="en-US" sz="1400" dirty="0">
+                <a:solidFill>
+                  <a:schemeClr val="tx1"/>
+                </a:solidFill>
+              </a:rPr>
+            </a:br>
+            <a:r>
+              <a:rPr lang="en-US" sz="1400" dirty="0">
+                <a:solidFill>
+                  <a:schemeClr val="tx1"/>
+                </a:solidFill>
+              </a:rPr>
+              <a:t>5</a:t>
+            </a:r>
+            <a:br>
+              <a:rPr lang="en-US" sz="1400" dirty="0">
+                <a:solidFill>
+                  <a:schemeClr val="tx1"/>
+                </a:solidFill>
+              </a:rPr>
+            </a:br>
+            <a:r>
+              <a:rPr lang="en-US" sz="1400" dirty="0">
+                <a:solidFill>
+                  <a:schemeClr val="tx1"/>
+                </a:solidFill>
+              </a:rPr>
+              <a:t>1</a:t>
+            </a:r>
+          </a:p>
+        </p:txBody>
+      </p:sp>
     </p:spTree>
     <p:extLst>
       <p:ext uri="{BB962C8B-B14F-4D97-AF65-F5344CB8AC3E}">
@@ -8107,15 +8496,7 @@
           <a:p>
             <a:r>
               <a:rPr lang="en-US" dirty="0"/>
-              <a:t>Positional </a:t>
-            </a:r>
-            <a:r>
-              <a:rPr lang="en-US"/>
-              <a:t>Encodings (2/2</a:t>
-            </a:r>
-            <a:r>
-              <a:rPr lang="en-US" dirty="0"/>
-              <a:t>)</a:t>
+              <a:t>Positional Encodings (2/2)</a:t>
             </a:r>
           </a:p>
         </p:txBody>

</xml_diff>

<commit_message>
Workshop 2: Clarify positional embeddings
</commit_message>
<xml_diff>
--- a/workshop-2-tokenization.pptx
+++ b/workshop-2-tokenization.pptx
@@ -8732,6 +8732,13 @@
             <a:r>
               <a:rPr lang="en-US" dirty="0"/>
               <a:t>Our positional embeddings are absolute and pretrained (same as GPT)</a:t>
+            </a:r>
+          </a:p>
+          <a:p>
+            <a:pPr lvl="1"/>
+            <a:r>
+              <a:rPr lang="en-US" dirty="0"/>
+              <a:t>This is why our final input embedding is the sum of two neural embedding layers.</a:t>
             </a:r>
           </a:p>
         </p:txBody>

</xml_diff>

<commit_message>
Workshop 2 add section slide
</commit_message>
<xml_diff>
--- a/workshop-2-tokenization.pptx
+++ b/workshop-2-tokenization.pptx
@@ -17,28 +17,29 @@
     <p:sldId id="267" r:id="rId11"/>
     <p:sldId id="268" r:id="rId12"/>
     <p:sldId id="269" r:id="rId13"/>
-    <p:sldId id="271" r:id="rId14"/>
-    <p:sldId id="273" r:id="rId15"/>
-    <p:sldId id="272" r:id="rId16"/>
-    <p:sldId id="274" r:id="rId17"/>
-    <p:sldId id="281" r:id="rId18"/>
-    <p:sldId id="276" r:id="rId19"/>
-    <p:sldId id="278" r:id="rId20"/>
-    <p:sldId id="279" r:id="rId21"/>
-    <p:sldId id="280" r:id="rId22"/>
-    <p:sldId id="282" r:id="rId23"/>
-    <p:sldId id="284" r:id="rId24"/>
-    <p:sldId id="285" r:id="rId25"/>
-    <p:sldId id="286" r:id="rId26"/>
-    <p:sldId id="287" r:id="rId27"/>
-    <p:sldId id="288" r:id="rId28"/>
-    <p:sldId id="289" r:id="rId29"/>
-    <p:sldId id="290" r:id="rId30"/>
-    <p:sldId id="291" r:id="rId31"/>
-    <p:sldId id="292" r:id="rId32"/>
-    <p:sldId id="293" r:id="rId33"/>
-    <p:sldId id="294" r:id="rId34"/>
-    <p:sldId id="295" r:id="rId35"/>
+    <p:sldId id="296" r:id="rId14"/>
+    <p:sldId id="271" r:id="rId15"/>
+    <p:sldId id="273" r:id="rId16"/>
+    <p:sldId id="272" r:id="rId17"/>
+    <p:sldId id="274" r:id="rId18"/>
+    <p:sldId id="281" r:id="rId19"/>
+    <p:sldId id="276" r:id="rId20"/>
+    <p:sldId id="278" r:id="rId21"/>
+    <p:sldId id="279" r:id="rId22"/>
+    <p:sldId id="280" r:id="rId23"/>
+    <p:sldId id="282" r:id="rId24"/>
+    <p:sldId id="284" r:id="rId25"/>
+    <p:sldId id="285" r:id="rId26"/>
+    <p:sldId id="286" r:id="rId27"/>
+    <p:sldId id="287" r:id="rId28"/>
+    <p:sldId id="288" r:id="rId29"/>
+    <p:sldId id="289" r:id="rId30"/>
+    <p:sldId id="290" r:id="rId31"/>
+    <p:sldId id="291" r:id="rId32"/>
+    <p:sldId id="292" r:id="rId33"/>
+    <p:sldId id="293" r:id="rId34"/>
+    <p:sldId id="294" r:id="rId35"/>
+    <p:sldId id="295" r:id="rId36"/>
   </p:sldIdLst>
   <p:sldSz cx="12192000" cy="6858000"/>
   <p:notesSz cx="6858000" cy="9144000"/>
@@ -4786,6 +4787,89 @@
           <p:cNvPr id="2" name="Title 1">
             <a:extLst>
               <a:ext uri="{FF2B5EF4-FFF2-40B4-BE49-F238E27FC236}">
+                <a16:creationId xmlns:a16="http://schemas.microsoft.com/office/drawing/2014/main" id="{CD461FFF-8CF3-123B-2B1F-DEE74E90B5A5}"/>
+              </a:ext>
+            </a:extLst>
+          </p:cNvPr>
+          <p:cNvSpPr>
+            <a:spLocks noGrp="1"/>
+          </p:cNvSpPr>
+          <p:nvPr>
+            <p:ph type="title"/>
+          </p:nvPr>
+        </p:nvSpPr>
+        <p:spPr/>
+        <p:txBody>
+          <a:bodyPr/>
+          <a:lstStyle/>
+          <a:p>
+            <a:r>
+              <a:rPr lang="en-US" dirty="0"/>
+              <a:t>Tokenization</a:t>
+            </a:r>
+          </a:p>
+        </p:txBody>
+      </p:sp>
+      <p:sp>
+        <p:nvSpPr>
+          <p:cNvPr id="3" name="Text Placeholder 2">
+            <a:extLst>
+              <a:ext uri="{FF2B5EF4-FFF2-40B4-BE49-F238E27FC236}">
+                <a16:creationId xmlns:a16="http://schemas.microsoft.com/office/drawing/2014/main" id="{1214BE71-E114-6C69-FEF2-0B3890130C10}"/>
+              </a:ext>
+            </a:extLst>
+          </p:cNvPr>
+          <p:cNvSpPr>
+            <a:spLocks noGrp="1"/>
+          </p:cNvSpPr>
+          <p:nvPr>
+            <p:ph type="body" idx="1"/>
+          </p:nvPr>
+        </p:nvSpPr>
+        <p:spPr/>
+        <p:txBody>
+          <a:bodyPr/>
+          <a:lstStyle/>
+          <a:p>
+            <a:endParaRPr lang="en-US"/>
+          </a:p>
+        </p:txBody>
+      </p:sp>
+    </p:spTree>
+    <p:extLst>
+      <p:ext uri="{BB962C8B-B14F-4D97-AF65-F5344CB8AC3E}">
+        <p14:creationId xmlns:p14="http://schemas.microsoft.com/office/powerpoint/2010/main" val="169215046"/>
+      </p:ext>
+    </p:extLst>
+  </p:cSld>
+  <p:clrMapOvr>
+    <a:masterClrMapping/>
+  </p:clrMapOvr>
+</p:sld>
+</file>
+
+<file path=ppt/slides/slide14.xml><?xml version="1.0" encoding="utf-8"?>
+<p:sld xmlns:a="http://schemas.openxmlformats.org/drawingml/2006/main" xmlns:r="http://schemas.openxmlformats.org/officeDocument/2006/relationships" xmlns:p="http://schemas.openxmlformats.org/presentationml/2006/main">
+  <p:cSld>
+    <p:spTree>
+      <p:nvGrpSpPr>
+        <p:cNvPr id="1" name=""/>
+        <p:cNvGrpSpPr/>
+        <p:nvPr/>
+      </p:nvGrpSpPr>
+      <p:grpSpPr>
+        <a:xfrm>
+          <a:off x="0" y="0"/>
+          <a:ext cx="0" cy="0"/>
+          <a:chOff x="0" y="0"/>
+          <a:chExt cx="0" cy="0"/>
+        </a:xfrm>
+      </p:grpSpPr>
+      <p:sp>
+        <p:nvSpPr>
+          <p:cNvPr id="2" name="Title 1">
+            <a:extLst>
+              <a:ext uri="{FF2B5EF4-FFF2-40B4-BE49-F238E27FC236}">
                 <a16:creationId xmlns:a16="http://schemas.microsoft.com/office/drawing/2014/main" id="{C093E392-3E22-968E-37F2-9ABFCB34D6EF}"/>
               </a:ext>
             </a:extLst>
@@ -4888,7 +4972,7 @@
 </p:sld>
 </file>
 
-<file path=ppt/slides/slide14.xml><?xml version="1.0" encoding="utf-8"?>
+<file path=ppt/slides/slide15.xml><?xml version="1.0" encoding="utf-8"?>
 <p:sld xmlns:a="http://schemas.openxmlformats.org/drawingml/2006/main" xmlns:r="http://schemas.openxmlformats.org/officeDocument/2006/relationships" xmlns:p="http://schemas.openxmlformats.org/presentationml/2006/main">
   <p:cSld>
     <p:spTree>
@@ -5024,165 +5108,6 @@
 </p:sld>
 </file>
 
-<file path=ppt/slides/slide15.xml><?xml version="1.0" encoding="utf-8"?>
-<p:sld xmlns:a="http://schemas.openxmlformats.org/drawingml/2006/main" xmlns:r="http://schemas.openxmlformats.org/officeDocument/2006/relationships" xmlns:p="http://schemas.openxmlformats.org/presentationml/2006/main">
-  <p:cSld>
-    <p:spTree>
-      <p:nvGrpSpPr>
-        <p:cNvPr id="1" name=""/>
-        <p:cNvGrpSpPr/>
-        <p:nvPr/>
-      </p:nvGrpSpPr>
-      <p:grpSpPr>
-        <a:xfrm>
-          <a:off x="0" y="0"/>
-          <a:ext cx="0" cy="0"/>
-          <a:chOff x="0" y="0"/>
-          <a:chExt cx="0" cy="0"/>
-        </a:xfrm>
-      </p:grpSpPr>
-      <p:sp>
-        <p:nvSpPr>
-          <p:cNvPr id="2" name="Title 1">
-            <a:extLst>
-              <a:ext uri="{FF2B5EF4-FFF2-40B4-BE49-F238E27FC236}">
-                <a16:creationId xmlns:a16="http://schemas.microsoft.com/office/drawing/2014/main" id="{2DF5E074-2073-5324-4F86-F768E9477A65}"/>
-              </a:ext>
-            </a:extLst>
-          </p:cNvPr>
-          <p:cNvSpPr>
-            <a:spLocks noGrp="1"/>
-          </p:cNvSpPr>
-          <p:nvPr>
-            <p:ph type="title"/>
-          </p:nvPr>
-        </p:nvSpPr>
-        <p:spPr/>
-        <p:txBody>
-          <a:bodyPr/>
-          <a:lstStyle/>
-          <a:p>
-            <a:r>
-              <a:rPr lang="en-US" dirty="0"/>
-              <a:t>Activity (5 minutes)</a:t>
-            </a:r>
-          </a:p>
-        </p:txBody>
-      </p:sp>
-      <p:sp>
-        <p:nvSpPr>
-          <p:cNvPr id="3" name="Content Placeholder 2">
-            <a:extLst>
-              <a:ext uri="{FF2B5EF4-FFF2-40B4-BE49-F238E27FC236}">
-                <a16:creationId xmlns:a16="http://schemas.microsoft.com/office/drawing/2014/main" id="{8A7157EF-CE41-1D9D-54A5-4D09588C6AE7}"/>
-              </a:ext>
-            </a:extLst>
-          </p:cNvPr>
-          <p:cNvSpPr>
-            <a:spLocks noGrp="1"/>
-          </p:cNvSpPr>
-          <p:nvPr>
-            <p:ph idx="1"/>
-          </p:nvPr>
-        </p:nvSpPr>
-        <p:spPr>
-          <a:xfrm>
-            <a:off x="838200" y="1825625"/>
-            <a:ext cx="10756900" cy="4351338"/>
-          </a:xfrm>
-        </p:spPr>
-        <p:txBody>
-          <a:bodyPr>
-            <a:normAutofit lnSpcReduction="10000"/>
-          </a:bodyPr>
-          <a:lstStyle/>
-          <a:p>
-            <a:r>
-              <a:rPr lang="en-US" i="1" dirty="0"/>
-              <a:t>[Work on section 2.2 of the notebook]</a:t>
-            </a:r>
-          </a:p>
-          <a:p>
-            <a:r>
-              <a:rPr lang="en-US" dirty="0"/>
-              <a:t>We will use Python’s </a:t>
-            </a:r>
-            <a:r>
-              <a:rPr lang="en-US" i="1" dirty="0"/>
-              <a:t>regular expressions </a:t>
-            </a:r>
-            <a:r>
-              <a:rPr lang="en-US" dirty="0"/>
-              <a:t>to tokenize our input text, “The Verdict” by Edith Wharton.</a:t>
-            </a:r>
-          </a:p>
-          <a:p>
-            <a:pPr lvl="1"/>
-            <a:r>
-              <a:rPr lang="en-US" dirty="0"/>
-              <a:t>Regular expressions (regex) are a very powerful tool for parsing text.</a:t>
-            </a:r>
-          </a:p>
-          <a:p>
-            <a:pPr lvl="1"/>
-            <a:r>
-              <a:rPr lang="en-US" dirty="0"/>
-              <a:t>You give the regex engine a specification of a pattern, as a string in Python’s regular expression syntax.  </a:t>
-            </a:r>
-          </a:p>
-          <a:p>
-            <a:pPr lvl="1"/>
-            <a:r>
-              <a:rPr lang="en-US" dirty="0"/>
-              <a:t>We will use the split functionality to split over certain characters.</a:t>
-            </a:r>
-          </a:p>
-          <a:p>
-            <a:r>
-              <a:rPr lang="en-US" dirty="0"/>
-              <a:t>Because whitespace and punctuation are semantically important, they should remain in the tokenization.</a:t>
-            </a:r>
-          </a:p>
-          <a:p>
-            <a:r>
-              <a:rPr lang="en-US" sz="2400" dirty="0">
-                <a:latin typeface="Courier New" panose="02070309020205020404" pitchFamily="49" charset="0"/>
-                <a:cs typeface="Courier New" panose="02070309020205020404" pitchFamily="49" charset="0"/>
-              </a:rPr>
-              <a:t>“Once upon a time…” </a:t>
-            </a:r>
-            <a:br>
-              <a:rPr lang="en-US" sz="2400" dirty="0">
-                <a:latin typeface="Courier New" panose="02070309020205020404" pitchFamily="49" charset="0"/>
-                <a:cs typeface="Courier New" panose="02070309020205020404" pitchFamily="49" charset="0"/>
-              </a:rPr>
-            </a:br>
-            <a:r>
-              <a:rPr lang="en-US" sz="2400" dirty="0">
-                <a:latin typeface="Courier New" panose="02070309020205020404" pitchFamily="49" charset="0"/>
-                <a:cs typeface="Courier New" panose="02070309020205020404" pitchFamily="49" charset="0"/>
-              </a:rPr>
-              <a:t>-&gt; [“Once”, “␣”, “upon”, “␣”, “a”, “␣”, “time”, “…”]</a:t>
-            </a:r>
-          </a:p>
-          <a:p>
-            <a:endParaRPr lang="en-US" dirty="0"/>
-          </a:p>
-        </p:txBody>
-      </p:sp>
-    </p:spTree>
-    <p:extLst>
-      <p:ext uri="{BB962C8B-B14F-4D97-AF65-F5344CB8AC3E}">
-        <p14:creationId xmlns:p14="http://schemas.microsoft.com/office/powerpoint/2010/main" val="1305503512"/>
-      </p:ext>
-    </p:extLst>
-  </p:cSld>
-  <p:clrMapOvr>
-    <a:masterClrMapping/>
-  </p:clrMapOvr>
-</p:sld>
-</file>
-
 <file path=ppt/slides/slide16.xml><?xml version="1.0" encoding="utf-8"?>
 <p:sld xmlns:a="http://schemas.openxmlformats.org/drawingml/2006/main" xmlns:r="http://schemas.openxmlformats.org/officeDocument/2006/relationships" xmlns:p="http://schemas.openxmlformats.org/presentationml/2006/main">
   <p:cSld>
@@ -5205,6 +5130,165 @@
           <p:cNvPr id="2" name="Title 1">
             <a:extLst>
               <a:ext uri="{FF2B5EF4-FFF2-40B4-BE49-F238E27FC236}">
+                <a16:creationId xmlns:a16="http://schemas.microsoft.com/office/drawing/2014/main" id="{2DF5E074-2073-5324-4F86-F768E9477A65}"/>
+              </a:ext>
+            </a:extLst>
+          </p:cNvPr>
+          <p:cNvSpPr>
+            <a:spLocks noGrp="1"/>
+          </p:cNvSpPr>
+          <p:nvPr>
+            <p:ph type="title"/>
+          </p:nvPr>
+        </p:nvSpPr>
+        <p:spPr/>
+        <p:txBody>
+          <a:bodyPr/>
+          <a:lstStyle/>
+          <a:p>
+            <a:r>
+              <a:rPr lang="en-US" dirty="0"/>
+              <a:t>Activity (5 minutes)</a:t>
+            </a:r>
+          </a:p>
+        </p:txBody>
+      </p:sp>
+      <p:sp>
+        <p:nvSpPr>
+          <p:cNvPr id="3" name="Content Placeholder 2">
+            <a:extLst>
+              <a:ext uri="{FF2B5EF4-FFF2-40B4-BE49-F238E27FC236}">
+                <a16:creationId xmlns:a16="http://schemas.microsoft.com/office/drawing/2014/main" id="{8A7157EF-CE41-1D9D-54A5-4D09588C6AE7}"/>
+              </a:ext>
+            </a:extLst>
+          </p:cNvPr>
+          <p:cNvSpPr>
+            <a:spLocks noGrp="1"/>
+          </p:cNvSpPr>
+          <p:nvPr>
+            <p:ph idx="1"/>
+          </p:nvPr>
+        </p:nvSpPr>
+        <p:spPr>
+          <a:xfrm>
+            <a:off x="838200" y="1825625"/>
+            <a:ext cx="10756900" cy="4351338"/>
+          </a:xfrm>
+        </p:spPr>
+        <p:txBody>
+          <a:bodyPr>
+            <a:normAutofit lnSpcReduction="10000"/>
+          </a:bodyPr>
+          <a:lstStyle/>
+          <a:p>
+            <a:r>
+              <a:rPr lang="en-US" i="1" dirty="0"/>
+              <a:t>[Work on section 2.2 of the notebook]</a:t>
+            </a:r>
+          </a:p>
+          <a:p>
+            <a:r>
+              <a:rPr lang="en-US" dirty="0"/>
+              <a:t>We will use Python’s </a:t>
+            </a:r>
+            <a:r>
+              <a:rPr lang="en-US" i="1" dirty="0"/>
+              <a:t>regular expressions </a:t>
+            </a:r>
+            <a:r>
+              <a:rPr lang="en-US" dirty="0"/>
+              <a:t>to tokenize our input text, “The Verdict” by Edith Wharton.</a:t>
+            </a:r>
+          </a:p>
+          <a:p>
+            <a:pPr lvl="1"/>
+            <a:r>
+              <a:rPr lang="en-US" dirty="0"/>
+              <a:t>Regular expressions (regex) are a very powerful tool for parsing text.</a:t>
+            </a:r>
+          </a:p>
+          <a:p>
+            <a:pPr lvl="1"/>
+            <a:r>
+              <a:rPr lang="en-US" dirty="0"/>
+              <a:t>You give the regex engine a specification of a pattern, as a string in Python’s regular expression syntax.  </a:t>
+            </a:r>
+          </a:p>
+          <a:p>
+            <a:pPr lvl="1"/>
+            <a:r>
+              <a:rPr lang="en-US" dirty="0"/>
+              <a:t>We will use the split functionality to split over certain characters.</a:t>
+            </a:r>
+          </a:p>
+          <a:p>
+            <a:r>
+              <a:rPr lang="en-US" dirty="0"/>
+              <a:t>Because whitespace and punctuation are semantically important, they should remain in the tokenization.</a:t>
+            </a:r>
+          </a:p>
+          <a:p>
+            <a:r>
+              <a:rPr lang="en-US" sz="2400" dirty="0">
+                <a:latin typeface="Courier New" panose="02070309020205020404" pitchFamily="49" charset="0"/>
+                <a:cs typeface="Courier New" panose="02070309020205020404" pitchFamily="49" charset="0"/>
+              </a:rPr>
+              <a:t>“Once upon a time…” </a:t>
+            </a:r>
+            <a:br>
+              <a:rPr lang="en-US" sz="2400" dirty="0">
+                <a:latin typeface="Courier New" panose="02070309020205020404" pitchFamily="49" charset="0"/>
+                <a:cs typeface="Courier New" panose="02070309020205020404" pitchFamily="49" charset="0"/>
+              </a:rPr>
+            </a:br>
+            <a:r>
+              <a:rPr lang="en-US" sz="2400" dirty="0">
+                <a:latin typeface="Courier New" panose="02070309020205020404" pitchFamily="49" charset="0"/>
+                <a:cs typeface="Courier New" panose="02070309020205020404" pitchFamily="49" charset="0"/>
+              </a:rPr>
+              <a:t>-&gt; [“Once”, “␣”, “upon”, “␣”, “a”, “␣”, “time”, “…”]</a:t>
+            </a:r>
+          </a:p>
+          <a:p>
+            <a:endParaRPr lang="en-US" dirty="0"/>
+          </a:p>
+        </p:txBody>
+      </p:sp>
+    </p:spTree>
+    <p:extLst>
+      <p:ext uri="{BB962C8B-B14F-4D97-AF65-F5344CB8AC3E}">
+        <p14:creationId xmlns:p14="http://schemas.microsoft.com/office/powerpoint/2010/main" val="1305503512"/>
+      </p:ext>
+    </p:extLst>
+  </p:cSld>
+  <p:clrMapOvr>
+    <a:masterClrMapping/>
+  </p:clrMapOvr>
+</p:sld>
+</file>
+
+<file path=ppt/slides/slide17.xml><?xml version="1.0" encoding="utf-8"?>
+<p:sld xmlns:a="http://schemas.openxmlformats.org/drawingml/2006/main" xmlns:r="http://schemas.openxmlformats.org/officeDocument/2006/relationships" xmlns:p="http://schemas.openxmlformats.org/presentationml/2006/main">
+  <p:cSld>
+    <p:spTree>
+      <p:nvGrpSpPr>
+        <p:cNvPr id="1" name=""/>
+        <p:cNvGrpSpPr/>
+        <p:nvPr/>
+      </p:nvGrpSpPr>
+      <p:grpSpPr>
+        <a:xfrm>
+          <a:off x="0" y="0"/>
+          <a:ext cx="0" cy="0"/>
+          <a:chOff x="0" y="0"/>
+          <a:chExt cx="0" cy="0"/>
+        </a:xfrm>
+      </p:grpSpPr>
+      <p:sp>
+        <p:nvSpPr>
+          <p:cNvPr id="2" name="Title 1">
+            <a:extLst>
+              <a:ext uri="{FF2B5EF4-FFF2-40B4-BE49-F238E27FC236}">
                 <a16:creationId xmlns:a16="http://schemas.microsoft.com/office/drawing/2014/main" id="{56846BF3-C812-7718-B708-AE3C7A889711}"/>
               </a:ext>
             </a:extLst>
@@ -5289,7 +5373,7 @@
 </p:sld>
 </file>
 
-<file path=ppt/slides/slide17.xml><?xml version="1.0" encoding="utf-8"?>
+<file path=ppt/slides/slide18.xml><?xml version="1.0" encoding="utf-8"?>
 <p:sld xmlns:a="http://schemas.openxmlformats.org/drawingml/2006/main" xmlns:r="http://schemas.openxmlformats.org/officeDocument/2006/relationships" xmlns:p="http://schemas.openxmlformats.org/presentationml/2006/main">
   <p:cSld>
     <p:spTree>
@@ -5482,7 +5566,7 @@
 </p:sld>
 </file>
 
-<file path=ppt/slides/slide18.xml><?xml version="1.0" encoding="utf-8"?>
+<file path=ppt/slides/slide19.xml><?xml version="1.0" encoding="utf-8"?>
 <p:sld xmlns:a="http://schemas.openxmlformats.org/drawingml/2006/main" xmlns:r="http://schemas.openxmlformats.org/officeDocument/2006/relationships" xmlns:p="http://schemas.openxmlformats.org/presentationml/2006/main">
   <p:cSld>
     <p:spTree>
@@ -5578,139 +5662,6 @@
 </p:sld>
 </file>
 
-<file path=ppt/slides/slide19.xml><?xml version="1.0" encoding="utf-8"?>
-<p:sld xmlns:a="http://schemas.openxmlformats.org/drawingml/2006/main" xmlns:r="http://schemas.openxmlformats.org/officeDocument/2006/relationships" xmlns:p="http://schemas.openxmlformats.org/presentationml/2006/main">
-  <p:cSld>
-    <p:spTree>
-      <p:nvGrpSpPr>
-        <p:cNvPr id="1" name=""/>
-        <p:cNvGrpSpPr/>
-        <p:nvPr/>
-      </p:nvGrpSpPr>
-      <p:grpSpPr>
-        <a:xfrm>
-          <a:off x="0" y="0"/>
-          <a:ext cx="0" cy="0"/>
-          <a:chOff x="0" y="0"/>
-          <a:chExt cx="0" cy="0"/>
-        </a:xfrm>
-      </p:grpSpPr>
-      <p:sp>
-        <p:nvSpPr>
-          <p:cNvPr id="2" name="Title 1">
-            <a:extLst>
-              <a:ext uri="{FF2B5EF4-FFF2-40B4-BE49-F238E27FC236}">
-                <a16:creationId xmlns:a16="http://schemas.microsoft.com/office/drawing/2014/main" id="{0DA107DB-8E18-22EC-5F43-D375AE3F9D3F}"/>
-              </a:ext>
-            </a:extLst>
-          </p:cNvPr>
-          <p:cNvSpPr>
-            <a:spLocks noGrp="1"/>
-          </p:cNvSpPr>
-          <p:nvPr>
-            <p:ph type="title"/>
-          </p:nvPr>
-        </p:nvSpPr>
-        <p:spPr/>
-        <p:txBody>
-          <a:bodyPr/>
-          <a:lstStyle/>
-          <a:p>
-            <a:r>
-              <a:rPr lang="en-US" dirty="0"/>
-              <a:t>Activity (5 minutes)</a:t>
-            </a:r>
-          </a:p>
-        </p:txBody>
-      </p:sp>
-      <p:sp>
-        <p:nvSpPr>
-          <p:cNvPr id="3" name="Content Placeholder 2">
-            <a:extLst>
-              <a:ext uri="{FF2B5EF4-FFF2-40B4-BE49-F238E27FC236}">
-                <a16:creationId xmlns:a16="http://schemas.microsoft.com/office/drawing/2014/main" id="{E0D87E40-F060-A9D9-8F77-B28E2FAD8378}"/>
-              </a:ext>
-            </a:extLst>
-          </p:cNvPr>
-          <p:cNvSpPr>
-            <a:spLocks noGrp="1"/>
-          </p:cNvSpPr>
-          <p:nvPr>
-            <p:ph idx="1"/>
-          </p:nvPr>
-        </p:nvSpPr>
-        <p:spPr/>
-        <p:txBody>
-          <a:bodyPr/>
-          <a:lstStyle/>
-          <a:p>
-            <a:r>
-              <a:rPr lang="en-US" i="1" dirty="0"/>
-              <a:t>[Work on section 2.3 of the notebook]</a:t>
-            </a:r>
-            <a:endParaRPr lang="en-US" dirty="0"/>
-          </a:p>
-          <a:p>
-            <a:r>
-              <a:rPr lang="en-US" dirty="0"/>
-              <a:t>Create IDs for our vocabulary</a:t>
-            </a:r>
-          </a:p>
-          <a:p>
-            <a:pPr marL="971550" lvl="1" indent="-514350">
-              <a:buFont typeface="+mj-lt"/>
-              <a:buAutoNum type="arabicPeriod"/>
-            </a:pPr>
-            <a:r>
-              <a:rPr lang="en-US" dirty="0"/>
-              <a:t>Sort tokens</a:t>
-            </a:r>
-          </a:p>
-          <a:p>
-            <a:pPr marL="971550" lvl="1" indent="-514350">
-              <a:buFont typeface="+mj-lt"/>
-              <a:buAutoNum type="arabicPeriod"/>
-            </a:pPr>
-            <a:r>
-              <a:rPr lang="en-US" dirty="0"/>
-              <a:t>Assign each token an ID in sorted order</a:t>
-            </a:r>
-          </a:p>
-          <a:p>
-            <a:r>
-              <a:rPr lang="en-US" dirty="0"/>
-              <a:t>Break down a new piece of text into token IDs</a:t>
-            </a:r>
-          </a:p>
-          <a:p>
-            <a:r>
-              <a:rPr lang="en-US" dirty="0"/>
-              <a:t>Note: Some text will give you a “</a:t>
-            </a:r>
-            <a:r>
-              <a:rPr lang="en-US" dirty="0" err="1"/>
-              <a:t>KeyError</a:t>
-            </a:r>
-            <a:r>
-              <a:rPr lang="en-US" dirty="0"/>
-              <a:t>” — this means that the token we want is not in the vocabulary. We will look at one way to deal with this in the next section.</a:t>
-            </a:r>
-          </a:p>
-        </p:txBody>
-      </p:sp>
-    </p:spTree>
-    <p:extLst>
-      <p:ext uri="{BB962C8B-B14F-4D97-AF65-F5344CB8AC3E}">
-        <p14:creationId xmlns:p14="http://schemas.microsoft.com/office/powerpoint/2010/main" val="3385414896"/>
-      </p:ext>
-    </p:extLst>
-  </p:cSld>
-  <p:clrMapOvr>
-    <a:masterClrMapping/>
-  </p:clrMapOvr>
-</p:sld>
-</file>
-
 <file path=ppt/slides/slide2.xml><?xml version="1.0" encoding="utf-8"?>
 <p:sld xmlns:a="http://schemas.openxmlformats.org/drawingml/2006/main" xmlns:r="http://schemas.openxmlformats.org/officeDocument/2006/relationships" xmlns:p="http://schemas.openxmlformats.org/presentationml/2006/main">
   <p:cSld>
@@ -5861,7 +5812,7 @@
             </a:r>
             <a:r>
               <a:rPr lang="en-US" dirty="0">
-                <a:hlinkClick r:id="rId6" action="ppaction://hlinksldjump"/>
+                <a:hlinkClick r:id="rId5" action="ppaction://hlinksldjump"/>
               </a:rPr>
               <a:t> IDs</a:t>
             </a:r>
@@ -5881,7 +5832,7 @@
             </a:r>
             <a:r>
               <a:rPr lang="en-US" dirty="0">
-                <a:hlinkClick r:id="rId7" action="ppaction://hlinksldjump"/>
+                <a:hlinkClick r:id="rId6" action="ppaction://hlinksldjump"/>
               </a:rPr>
               <a:t>Special Tokens</a:t>
             </a:r>
@@ -5901,7 +5852,7 @@
             </a:r>
             <a:r>
               <a:rPr lang="en-US" dirty="0">
-                <a:hlinkClick r:id="rId8" action="ppaction://hlinksldjump"/>
+                <a:hlinkClick r:id="rId7" action="ppaction://hlinksldjump"/>
               </a:rPr>
               <a:t>Byte Pair Encoding</a:t>
             </a:r>
@@ -5921,7 +5872,7 @@
             </a:r>
             <a:r>
               <a:rPr lang="en-US" dirty="0">
-                <a:hlinkClick r:id="rId9" action="ppaction://hlinksldjump"/>
+                <a:hlinkClick r:id="rId8" action="ppaction://hlinksldjump"/>
               </a:rPr>
               <a:t>Sliding Window Data Loader</a:t>
             </a:r>
@@ -5951,7 +5902,7 @@
             </a:r>
             <a:r>
               <a:rPr lang="en-US" dirty="0">
-                <a:hlinkClick r:id="rId10" action="ppaction://hlinksldjump"/>
+                <a:hlinkClick r:id="rId9" action="ppaction://hlinksldjump"/>
               </a:rPr>
               <a:t>Token Embeddings</a:t>
             </a:r>
@@ -5971,7 +5922,7 @@
             </a:r>
             <a:r>
               <a:rPr lang="en-US" dirty="0">
-                <a:hlinkClick r:id="rId11" action="ppaction://hlinksldjump"/>
+                <a:hlinkClick r:id="rId10" action="ppaction://hlinksldjump"/>
               </a:rPr>
               <a:t>Positional Embeddings</a:t>
             </a:r>
@@ -6017,6 +5968,139 @@
           <p:cNvPr id="2" name="Title 1">
             <a:extLst>
               <a:ext uri="{FF2B5EF4-FFF2-40B4-BE49-F238E27FC236}">
+                <a16:creationId xmlns:a16="http://schemas.microsoft.com/office/drawing/2014/main" id="{0DA107DB-8E18-22EC-5F43-D375AE3F9D3F}"/>
+              </a:ext>
+            </a:extLst>
+          </p:cNvPr>
+          <p:cNvSpPr>
+            <a:spLocks noGrp="1"/>
+          </p:cNvSpPr>
+          <p:nvPr>
+            <p:ph type="title"/>
+          </p:nvPr>
+        </p:nvSpPr>
+        <p:spPr/>
+        <p:txBody>
+          <a:bodyPr/>
+          <a:lstStyle/>
+          <a:p>
+            <a:r>
+              <a:rPr lang="en-US" dirty="0"/>
+              <a:t>Activity (5 minutes)</a:t>
+            </a:r>
+          </a:p>
+        </p:txBody>
+      </p:sp>
+      <p:sp>
+        <p:nvSpPr>
+          <p:cNvPr id="3" name="Content Placeholder 2">
+            <a:extLst>
+              <a:ext uri="{FF2B5EF4-FFF2-40B4-BE49-F238E27FC236}">
+                <a16:creationId xmlns:a16="http://schemas.microsoft.com/office/drawing/2014/main" id="{E0D87E40-F060-A9D9-8F77-B28E2FAD8378}"/>
+              </a:ext>
+            </a:extLst>
+          </p:cNvPr>
+          <p:cNvSpPr>
+            <a:spLocks noGrp="1"/>
+          </p:cNvSpPr>
+          <p:nvPr>
+            <p:ph idx="1"/>
+          </p:nvPr>
+        </p:nvSpPr>
+        <p:spPr/>
+        <p:txBody>
+          <a:bodyPr/>
+          <a:lstStyle/>
+          <a:p>
+            <a:r>
+              <a:rPr lang="en-US" i="1" dirty="0"/>
+              <a:t>[Work on section 2.3 of the notebook]</a:t>
+            </a:r>
+            <a:endParaRPr lang="en-US" dirty="0"/>
+          </a:p>
+          <a:p>
+            <a:r>
+              <a:rPr lang="en-US" dirty="0"/>
+              <a:t>Create IDs for our vocabulary</a:t>
+            </a:r>
+          </a:p>
+          <a:p>
+            <a:pPr marL="971550" lvl="1" indent="-514350">
+              <a:buFont typeface="+mj-lt"/>
+              <a:buAutoNum type="arabicPeriod"/>
+            </a:pPr>
+            <a:r>
+              <a:rPr lang="en-US" dirty="0"/>
+              <a:t>Sort tokens</a:t>
+            </a:r>
+          </a:p>
+          <a:p>
+            <a:pPr marL="971550" lvl="1" indent="-514350">
+              <a:buFont typeface="+mj-lt"/>
+              <a:buAutoNum type="arabicPeriod"/>
+            </a:pPr>
+            <a:r>
+              <a:rPr lang="en-US" dirty="0"/>
+              <a:t>Assign each token an ID in sorted order</a:t>
+            </a:r>
+          </a:p>
+          <a:p>
+            <a:r>
+              <a:rPr lang="en-US" dirty="0"/>
+              <a:t>Break down a new piece of text into token IDs</a:t>
+            </a:r>
+          </a:p>
+          <a:p>
+            <a:r>
+              <a:rPr lang="en-US" dirty="0"/>
+              <a:t>Note: Some text will give you a “</a:t>
+            </a:r>
+            <a:r>
+              <a:rPr lang="en-US" dirty="0" err="1"/>
+              <a:t>KeyError</a:t>
+            </a:r>
+            <a:r>
+              <a:rPr lang="en-US" dirty="0"/>
+              <a:t>” — this means that the token we want is not in the vocabulary. We will look at one way to deal with this in the next section.</a:t>
+            </a:r>
+          </a:p>
+        </p:txBody>
+      </p:sp>
+    </p:spTree>
+    <p:extLst>
+      <p:ext uri="{BB962C8B-B14F-4D97-AF65-F5344CB8AC3E}">
+        <p14:creationId xmlns:p14="http://schemas.microsoft.com/office/powerpoint/2010/main" val="3385414896"/>
+      </p:ext>
+    </p:extLst>
+  </p:cSld>
+  <p:clrMapOvr>
+    <a:masterClrMapping/>
+  </p:clrMapOvr>
+</p:sld>
+</file>
+
+<file path=ppt/slides/slide21.xml><?xml version="1.0" encoding="utf-8"?>
+<p:sld xmlns:a="http://schemas.openxmlformats.org/drawingml/2006/main" xmlns:r="http://schemas.openxmlformats.org/officeDocument/2006/relationships" xmlns:p="http://schemas.openxmlformats.org/presentationml/2006/main">
+  <p:cSld>
+    <p:spTree>
+      <p:nvGrpSpPr>
+        <p:cNvPr id="1" name=""/>
+        <p:cNvGrpSpPr/>
+        <p:nvPr/>
+      </p:nvGrpSpPr>
+      <p:grpSpPr>
+        <a:xfrm>
+          <a:off x="0" y="0"/>
+          <a:ext cx="0" cy="0"/>
+          <a:chOff x="0" y="0"/>
+          <a:chExt cx="0" cy="0"/>
+        </a:xfrm>
+      </p:grpSpPr>
+      <p:sp>
+        <p:nvSpPr>
+          <p:cNvPr id="2" name="Title 1">
+            <a:extLst>
+              <a:ext uri="{FF2B5EF4-FFF2-40B4-BE49-F238E27FC236}">
                 <a16:creationId xmlns:a16="http://schemas.microsoft.com/office/drawing/2014/main" id="{F95C2209-5826-72D1-EC27-60B77713807F}"/>
               </a:ext>
             </a:extLst>
@@ -6120,7 +6204,7 @@
 </p:sld>
 </file>
 
-<file path=ppt/slides/slide21.xml><?xml version="1.0" encoding="utf-8"?>
+<file path=ppt/slides/slide22.xml><?xml version="1.0" encoding="utf-8"?>
 <p:sld xmlns:a="http://schemas.openxmlformats.org/drawingml/2006/main" xmlns:r="http://schemas.openxmlformats.org/officeDocument/2006/relationships" xmlns:p="http://schemas.openxmlformats.org/presentationml/2006/main">
   <p:cSld>
     <p:spTree>
@@ -6463,7 +6547,7 @@
 </p:sld>
 </file>
 
-<file path=ppt/slides/slide22.xml><?xml version="1.0" encoding="utf-8"?>
+<file path=ppt/slides/slide23.xml><?xml version="1.0" encoding="utf-8"?>
 <p:sld xmlns:a="http://schemas.openxmlformats.org/drawingml/2006/main" xmlns:r="http://schemas.openxmlformats.org/officeDocument/2006/relationships" xmlns:p="http://schemas.openxmlformats.org/presentationml/2006/main">
   <p:cSld>
     <p:spTree>
@@ -6621,7 +6705,7 @@
 </p:sld>
 </file>
 
-<file path=ppt/slides/slide23.xml><?xml version="1.0" encoding="utf-8"?>
+<file path=ppt/slides/slide24.xml><?xml version="1.0" encoding="utf-8"?>
 <p:sld xmlns:a="http://schemas.openxmlformats.org/drawingml/2006/main" xmlns:r="http://schemas.openxmlformats.org/officeDocument/2006/relationships" xmlns:p="http://schemas.openxmlformats.org/presentationml/2006/main">
   <p:cSld>
     <p:spTree>
@@ -6725,89 +6809,6 @@
     <p:extLst>
       <p:ext uri="{BB962C8B-B14F-4D97-AF65-F5344CB8AC3E}">
         <p14:creationId xmlns:p14="http://schemas.microsoft.com/office/powerpoint/2010/main" val="1405491657"/>
-      </p:ext>
-    </p:extLst>
-  </p:cSld>
-  <p:clrMapOvr>
-    <a:masterClrMapping/>
-  </p:clrMapOvr>
-</p:sld>
-</file>
-
-<file path=ppt/slides/slide24.xml><?xml version="1.0" encoding="utf-8"?>
-<p:sld xmlns:a="http://schemas.openxmlformats.org/drawingml/2006/main" xmlns:r="http://schemas.openxmlformats.org/officeDocument/2006/relationships" xmlns:p="http://schemas.openxmlformats.org/presentationml/2006/main">
-  <p:cSld>
-    <p:spTree>
-      <p:nvGrpSpPr>
-        <p:cNvPr id="1" name=""/>
-        <p:cNvGrpSpPr/>
-        <p:nvPr/>
-      </p:nvGrpSpPr>
-      <p:grpSpPr>
-        <a:xfrm>
-          <a:off x="0" y="0"/>
-          <a:ext cx="0" cy="0"/>
-          <a:chOff x="0" y="0"/>
-          <a:chExt cx="0" cy="0"/>
-        </a:xfrm>
-      </p:grpSpPr>
-      <p:sp>
-        <p:nvSpPr>
-          <p:cNvPr id="2" name="Title 1">
-            <a:extLst>
-              <a:ext uri="{FF2B5EF4-FFF2-40B4-BE49-F238E27FC236}">
-                <a16:creationId xmlns:a16="http://schemas.microsoft.com/office/drawing/2014/main" id="{A59E4E68-8E5D-47F5-085F-D753B9E7A37B}"/>
-              </a:ext>
-            </a:extLst>
-          </p:cNvPr>
-          <p:cNvSpPr>
-            <a:spLocks noGrp="1"/>
-          </p:cNvSpPr>
-          <p:nvPr>
-            <p:ph type="title"/>
-          </p:nvPr>
-        </p:nvSpPr>
-        <p:spPr/>
-        <p:txBody>
-          <a:bodyPr/>
-          <a:lstStyle/>
-          <a:p>
-            <a:r>
-              <a:rPr lang="en-US" dirty="0"/>
-              <a:t>Sliding Window Data Loader</a:t>
-            </a:r>
-          </a:p>
-        </p:txBody>
-      </p:sp>
-      <p:sp>
-        <p:nvSpPr>
-          <p:cNvPr id="3" name="Text Placeholder 2">
-            <a:extLst>
-              <a:ext uri="{FF2B5EF4-FFF2-40B4-BE49-F238E27FC236}">
-                <a16:creationId xmlns:a16="http://schemas.microsoft.com/office/drawing/2014/main" id="{A602F058-82C5-5013-BDCC-2B7731AA2B8F}"/>
-              </a:ext>
-            </a:extLst>
-          </p:cNvPr>
-          <p:cNvSpPr>
-            <a:spLocks noGrp="1"/>
-          </p:cNvSpPr>
-          <p:nvPr>
-            <p:ph type="body" idx="1"/>
-          </p:nvPr>
-        </p:nvSpPr>
-        <p:spPr/>
-        <p:txBody>
-          <a:bodyPr/>
-          <a:lstStyle/>
-          <a:p>
-            <a:endParaRPr lang="en-US"/>
-          </a:p>
-        </p:txBody>
-      </p:sp>
-    </p:spTree>
-    <p:extLst>
-      <p:ext uri="{BB962C8B-B14F-4D97-AF65-F5344CB8AC3E}">
-        <p14:creationId xmlns:p14="http://schemas.microsoft.com/office/powerpoint/2010/main" val="92774988"/>
       </p:ext>
     </p:extLst>
   </p:cSld>
@@ -6839,7 +6840,7 @@
           <p:cNvPr id="2" name="Title 1">
             <a:extLst>
               <a:ext uri="{FF2B5EF4-FFF2-40B4-BE49-F238E27FC236}">
-                <a16:creationId xmlns:a16="http://schemas.microsoft.com/office/drawing/2014/main" id="{F758F5C5-C5E0-C643-D055-9986B7A7B422}"/>
+                <a16:creationId xmlns:a16="http://schemas.microsoft.com/office/drawing/2014/main" id="{A59E4E68-8E5D-47F5-085F-D753B9E7A37B}"/>
               </a:ext>
             </a:extLst>
           </p:cNvPr>
@@ -6857,55 +6858,25 @@
           <a:p>
             <a:r>
               <a:rPr lang="en-US" dirty="0"/>
-              <a:t>Input-Output Pairs</a:t>
-            </a:r>
-          </a:p>
-        </p:txBody>
-      </p:sp>
-      <p:pic>
-        <p:nvPicPr>
-          <p:cNvPr id="6" name="Picture Placeholder 5">
-            <a:extLst>
-              <a:ext uri="{FF2B5EF4-FFF2-40B4-BE49-F238E27FC236}">
-                <a16:creationId xmlns:a16="http://schemas.microsoft.com/office/drawing/2014/main" id="{EC67A5A7-DC9A-AE4C-F61C-B5E6D80717B2}"/>
-              </a:ext>
-            </a:extLst>
-          </p:cNvPr>
-          <p:cNvPicPr>
-            <a:picLocks noGrp="1" noChangeAspect="1"/>
-          </p:cNvPicPr>
-          <p:nvPr>
-            <p:ph type="pic" idx="1"/>
-          </p:nvPr>
-        </p:nvPicPr>
-        <p:blipFill>
-          <a:blip r:embed="rId2"/>
-          <a:srcRect l="-804" r="-52"/>
-          <a:stretch>
-            <a:fillRect/>
-          </a:stretch>
-        </p:blipFill>
-        <p:spPr>
-          <a:xfrm>
-            <a:off x="5183188" y="987425"/>
-            <a:ext cx="6172200" cy="4873625"/>
-          </a:xfrm>
-        </p:spPr>
-      </p:pic>
-      <p:sp>
-        <p:nvSpPr>
-          <p:cNvPr id="4" name="Text Placeholder 3">
-            <a:extLst>
-              <a:ext uri="{FF2B5EF4-FFF2-40B4-BE49-F238E27FC236}">
-                <a16:creationId xmlns:a16="http://schemas.microsoft.com/office/drawing/2014/main" id="{82F6EC3C-ECE6-F153-A8C1-B0A58EAA051C}"/>
-              </a:ext>
-            </a:extLst>
-          </p:cNvPr>
-          <p:cNvSpPr>
-            <a:spLocks noGrp="1"/>
-          </p:cNvSpPr>
-          <p:nvPr>
-            <p:ph type="body" sz="half" idx="2"/>
+              <a:t>Sliding Window Data Loader</a:t>
+            </a:r>
+          </a:p>
+        </p:txBody>
+      </p:sp>
+      <p:sp>
+        <p:nvSpPr>
+          <p:cNvPr id="3" name="Text Placeholder 2">
+            <a:extLst>
+              <a:ext uri="{FF2B5EF4-FFF2-40B4-BE49-F238E27FC236}">
+                <a16:creationId xmlns:a16="http://schemas.microsoft.com/office/drawing/2014/main" id="{A602F058-82C5-5013-BDCC-2B7731AA2B8F}"/>
+              </a:ext>
+            </a:extLst>
+          </p:cNvPr>
+          <p:cNvSpPr>
+            <a:spLocks noGrp="1"/>
+          </p:cNvSpPr>
+          <p:nvPr>
+            <p:ph type="body" idx="1"/>
           </p:nvPr>
         </p:nvSpPr>
         <p:spPr/>
@@ -6913,103 +6884,14 @@
           <a:bodyPr/>
           <a:lstStyle/>
           <a:p>
-            <a:pPr marL="285750" indent="-285750">
-              <a:buFont typeface="Arial" panose="020B0604020202020204" pitchFamily="34" charset="0"/>
-              <a:buChar char="•"/>
-            </a:pPr>
-            <a:r>
-              <a:rPr lang="en-US" dirty="0"/>
-              <a:t>When training an LLM, we predict one word at a time.</a:t>
-            </a:r>
-          </a:p>
-          <a:p>
-            <a:pPr marL="285750" indent="-285750">
-              <a:buFont typeface="Arial" panose="020B0604020202020204" pitchFamily="34" charset="0"/>
-              <a:buChar char="•"/>
-            </a:pPr>
-            <a:r>
-              <a:rPr lang="en-US" dirty="0"/>
-              <a:t> </a:t>
-            </a:r>
-            <a:r>
-              <a:rPr lang="en-US" dirty="0">
-                <a:highlight>
-                  <a:srgbClr val="00FFFF"/>
-                </a:highlight>
-              </a:rPr>
-              <a:t>Input</a:t>
-            </a:r>
-            <a:r>
-              <a:rPr lang="en-US" dirty="0"/>
-              <a:t>: Tokens coming before the word</a:t>
-            </a:r>
-          </a:p>
-          <a:p>
-            <a:pPr marL="285750" indent="-285750">
-              <a:buFont typeface="Arial" panose="020B0604020202020204" pitchFamily="34" charset="0"/>
-              <a:buChar char="•"/>
-            </a:pPr>
-            <a:r>
-              <a:rPr lang="en-US" dirty="0"/>
-              <a:t> </a:t>
-            </a:r>
-            <a:r>
-              <a:rPr lang="en-US" dirty="0">
-                <a:solidFill>
-                  <a:schemeClr val="bg1"/>
-                </a:solidFill>
-                <a:highlight>
-                  <a:srgbClr val="800000"/>
-                </a:highlight>
-              </a:rPr>
-              <a:t>Output</a:t>
-            </a:r>
-            <a:r>
-              <a:rPr lang="en-US" dirty="0"/>
-              <a:t>: The next word that the LLM should predict</a:t>
-            </a:r>
-          </a:p>
-        </p:txBody>
-      </p:sp>
-      <p:sp>
-        <p:nvSpPr>
-          <p:cNvPr id="7" name="TextBox 6">
-            <a:extLst>
-              <a:ext uri="{FF2B5EF4-FFF2-40B4-BE49-F238E27FC236}">
-                <a16:creationId xmlns:a16="http://schemas.microsoft.com/office/drawing/2014/main" id="{5E6F3F5D-3A3F-FD2C-0D91-A7792908EB46}"/>
-              </a:ext>
-            </a:extLst>
-          </p:cNvPr>
-          <p:cNvSpPr txBox="1"/>
-          <p:nvPr/>
-        </p:nvSpPr>
-        <p:spPr>
-          <a:xfrm>
-            <a:off x="4078525" y="6216134"/>
-            <a:ext cx="2017475" cy="369332"/>
-          </a:xfrm>
-          <a:prstGeom prst="rect">
-            <a:avLst/>
-          </a:prstGeom>
-          <a:noFill/>
-        </p:spPr>
-        <p:txBody>
-          <a:bodyPr wrap="none" rtlCol="0">
-            <a:spAutoFit/>
-          </a:bodyPr>
-          <a:lstStyle/>
-          <a:p>
-            <a:r>
-              <a:rPr lang="en-US" dirty="0"/>
-              <a:t>(Source: Textbook)</a:t>
-            </a:r>
+            <a:endParaRPr lang="en-US"/>
           </a:p>
         </p:txBody>
       </p:sp>
     </p:spTree>
     <p:extLst>
       <p:ext uri="{BB962C8B-B14F-4D97-AF65-F5344CB8AC3E}">
-        <p14:creationId xmlns:p14="http://schemas.microsoft.com/office/powerpoint/2010/main" val="533775668"/>
+        <p14:creationId xmlns:p14="http://schemas.microsoft.com/office/powerpoint/2010/main" val="92774988"/>
       </p:ext>
     </p:extLst>
   </p:cSld>
@@ -7041,7 +6923,7 @@
           <p:cNvPr id="2" name="Title 1">
             <a:extLst>
               <a:ext uri="{FF2B5EF4-FFF2-40B4-BE49-F238E27FC236}">
-                <a16:creationId xmlns:a16="http://schemas.microsoft.com/office/drawing/2014/main" id="{76428338-B99D-23B9-B2A7-AD0D449B837C}"/>
+                <a16:creationId xmlns:a16="http://schemas.microsoft.com/office/drawing/2014/main" id="{F758F5C5-C5E0-C643-D055-9986B7A7B422}"/>
               </a:ext>
             </a:extLst>
           </p:cNvPr>
@@ -7058,88 +6940,127 @@
           <a:lstStyle/>
           <a:p>
             <a:r>
-              <a:rPr lang="en-US" dirty="0" err="1"/>
-              <a:t>PyTorch</a:t>
-            </a:r>
-            <a:r>
-              <a:rPr lang="en-US" dirty="0"/>
-              <a:t> Data Loader</a:t>
-            </a:r>
-          </a:p>
-        </p:txBody>
-      </p:sp>
-      <p:sp>
-        <p:nvSpPr>
-          <p:cNvPr id="3" name="Content Placeholder 2">
-            <a:extLst>
-              <a:ext uri="{FF2B5EF4-FFF2-40B4-BE49-F238E27FC236}">
-                <a16:creationId xmlns:a16="http://schemas.microsoft.com/office/drawing/2014/main" id="{1BE08C13-506D-EEAE-70B9-E3E20CEC72C3}"/>
-              </a:ext>
-            </a:extLst>
-          </p:cNvPr>
-          <p:cNvSpPr>
-            <a:spLocks noGrp="1"/>
-          </p:cNvSpPr>
-          <p:nvPr>
-            <p:ph idx="1"/>
-          </p:nvPr>
-        </p:nvSpPr>
-        <p:spPr/>
-        <p:txBody>
-          <a:bodyPr/>
-          <a:lstStyle/>
-          <a:p>
-            <a:r>
-              <a:rPr lang="en-US" dirty="0"/>
-              <a:t>Goal: produce an efficient data loader that takes text and turns it into a </a:t>
-            </a:r>
-            <a:r>
-              <a:rPr lang="en-US" dirty="0" err="1"/>
-              <a:t>PyTorch</a:t>
-            </a:r>
-            <a:r>
-              <a:rPr lang="en-US" dirty="0"/>
-              <a:t> tensor of inputs and targets.</a:t>
+              <a:rPr lang="en-US" dirty="0"/>
+              <a:t>Input-Output Pairs</a:t>
             </a:r>
           </a:p>
         </p:txBody>
       </p:sp>
       <p:pic>
         <p:nvPicPr>
-          <p:cNvPr id="5" name="Picture 4">
-            <a:extLst>
-              <a:ext uri="{FF2B5EF4-FFF2-40B4-BE49-F238E27FC236}">
-                <a16:creationId xmlns:a16="http://schemas.microsoft.com/office/drawing/2014/main" id="{5410FB21-9389-B455-2DA4-5588FC5340C8}"/>
+          <p:cNvPr id="6" name="Picture Placeholder 5">
+            <a:extLst>
+              <a:ext uri="{FF2B5EF4-FFF2-40B4-BE49-F238E27FC236}">
+                <a16:creationId xmlns:a16="http://schemas.microsoft.com/office/drawing/2014/main" id="{EC67A5A7-DC9A-AE4C-F61C-B5E6D80717B2}"/>
               </a:ext>
             </a:extLst>
           </p:cNvPr>
           <p:cNvPicPr>
-            <a:picLocks noChangeAspect="1"/>
+            <a:picLocks noGrp="1" noChangeAspect="1"/>
           </p:cNvPicPr>
-          <p:nvPr/>
+          <p:nvPr>
+            <p:ph type="pic" idx="1"/>
+          </p:nvPr>
         </p:nvPicPr>
         <p:blipFill>
           <a:blip r:embed="rId2"/>
+          <a:srcRect l="-804" r="-52"/>
           <a:stretch>
             <a:fillRect/>
           </a:stretch>
         </p:blipFill>
         <p:spPr>
           <a:xfrm>
-            <a:off x="5472539" y="2645444"/>
-            <a:ext cx="6133618" cy="3403600"/>
+            <a:off x="5183188" y="987425"/>
+            <a:ext cx="6172200" cy="4873625"/>
           </a:xfrm>
-          <a:prstGeom prst="rect">
-            <a:avLst/>
-          </a:prstGeom>
         </p:spPr>
       </p:pic>
       <p:sp>
         <p:nvSpPr>
-          <p:cNvPr id="6" name="TextBox 5">
-            <a:extLst>
-              <a:ext uri="{FF2B5EF4-FFF2-40B4-BE49-F238E27FC236}">
-                <a16:creationId xmlns:a16="http://schemas.microsoft.com/office/drawing/2014/main" id="{DFADFC75-2FE4-5921-C83C-85E2E5418C8C}"/>
+          <p:cNvPr id="4" name="Text Placeholder 3">
+            <a:extLst>
+              <a:ext uri="{FF2B5EF4-FFF2-40B4-BE49-F238E27FC236}">
+                <a16:creationId xmlns:a16="http://schemas.microsoft.com/office/drawing/2014/main" id="{82F6EC3C-ECE6-F153-A8C1-B0A58EAA051C}"/>
+              </a:ext>
+            </a:extLst>
+          </p:cNvPr>
+          <p:cNvSpPr>
+            <a:spLocks noGrp="1"/>
+          </p:cNvSpPr>
+          <p:nvPr>
+            <p:ph type="body" sz="half" idx="2"/>
+          </p:nvPr>
+        </p:nvSpPr>
+        <p:spPr/>
+        <p:txBody>
+          <a:bodyPr/>
+          <a:lstStyle/>
+          <a:p>
+            <a:pPr marL="285750" indent="-285750">
+              <a:buFont typeface="Arial" panose="020B0604020202020204" pitchFamily="34" charset="0"/>
+              <a:buChar char="•"/>
+            </a:pPr>
+            <a:r>
+              <a:rPr lang="en-US" dirty="0"/>
+              <a:t>When training an LLM, we predict one word at a time.</a:t>
+            </a:r>
+          </a:p>
+          <a:p>
+            <a:pPr marL="285750" indent="-285750">
+              <a:buFont typeface="Arial" panose="020B0604020202020204" pitchFamily="34" charset="0"/>
+              <a:buChar char="•"/>
+            </a:pPr>
+            <a:r>
+              <a:rPr lang="en-US" dirty="0"/>
+              <a:t> </a:t>
+            </a:r>
+            <a:r>
+              <a:rPr lang="en-US" dirty="0">
+                <a:highlight>
+                  <a:srgbClr val="00FFFF"/>
+                </a:highlight>
+              </a:rPr>
+              <a:t>Input</a:t>
+            </a:r>
+            <a:r>
+              <a:rPr lang="en-US" dirty="0"/>
+              <a:t>: Tokens coming before the word</a:t>
+            </a:r>
+          </a:p>
+          <a:p>
+            <a:pPr marL="285750" indent="-285750">
+              <a:buFont typeface="Arial" panose="020B0604020202020204" pitchFamily="34" charset="0"/>
+              <a:buChar char="•"/>
+            </a:pPr>
+            <a:r>
+              <a:rPr lang="en-US" dirty="0"/>
+              <a:t> </a:t>
+            </a:r>
+            <a:r>
+              <a:rPr lang="en-US" dirty="0">
+                <a:solidFill>
+                  <a:schemeClr val="bg1"/>
+                </a:solidFill>
+                <a:highlight>
+                  <a:srgbClr val="800000"/>
+                </a:highlight>
+              </a:rPr>
+              <a:t>Output</a:t>
+            </a:r>
+            <a:r>
+              <a:rPr lang="en-US" dirty="0"/>
+              <a:t>: The next word that the LLM should predict</a:t>
+            </a:r>
+          </a:p>
+        </p:txBody>
+      </p:sp>
+      <p:sp>
+        <p:nvSpPr>
+          <p:cNvPr id="7" name="TextBox 6">
+            <a:extLst>
+              <a:ext uri="{FF2B5EF4-FFF2-40B4-BE49-F238E27FC236}">
+                <a16:creationId xmlns:a16="http://schemas.microsoft.com/office/drawing/2014/main" id="{5E6F3F5D-3A3F-FD2C-0D91-A7792908EB46}"/>
               </a:ext>
             </a:extLst>
           </p:cNvPr>
@@ -7148,7 +7069,7 @@
         </p:nvSpPr>
         <p:spPr>
           <a:xfrm>
-            <a:off x="7531100" y="6123543"/>
+            <a:off x="4078525" y="6216134"/>
             <a:ext cx="2017475" cy="369332"/>
           </a:xfrm>
           <a:prstGeom prst="rect">
@@ -7169,265 +7090,10 @@
           </a:p>
         </p:txBody>
       </p:sp>
-      <p:sp>
-        <p:nvSpPr>
-          <p:cNvPr id="7" name="Rectangle 6">
-            <a:extLst>
-              <a:ext uri="{FF2B5EF4-FFF2-40B4-BE49-F238E27FC236}">
-                <a16:creationId xmlns:a16="http://schemas.microsoft.com/office/drawing/2014/main" id="{6E400AEE-23B5-927D-4BA8-EABAD8426F1D}"/>
-              </a:ext>
-            </a:extLst>
-          </p:cNvPr>
-          <p:cNvSpPr/>
-          <p:nvPr/>
-        </p:nvSpPr>
-        <p:spPr>
-          <a:xfrm>
-            <a:off x="7962979" y="4679805"/>
-            <a:ext cx="416859" cy="250265"/>
-          </a:xfrm>
-          <a:prstGeom prst="rect">
-            <a:avLst/>
-          </a:prstGeom>
-        </p:spPr>
-        <p:style>
-          <a:lnRef idx="2">
-            <a:schemeClr val="accent1">
-              <a:shade val="15000"/>
-            </a:schemeClr>
-          </a:lnRef>
-          <a:fillRef idx="1">
-            <a:schemeClr val="accent1"/>
-          </a:fillRef>
-          <a:effectRef idx="0">
-            <a:schemeClr val="accent1"/>
-          </a:effectRef>
-          <a:fontRef idx="minor">
-            <a:schemeClr val="lt1"/>
-          </a:fontRef>
-        </p:style>
-        <p:txBody>
-          <a:bodyPr rtlCol="0" anchor="ctr"/>
-          <a:lstStyle/>
-          <a:p>
-            <a:pPr algn="ctr"/>
-            <a:r>
-              <a:rPr lang="en-US" dirty="0"/>
-              <a:t>In</a:t>
-            </a:r>
-          </a:p>
-        </p:txBody>
-      </p:sp>
-      <p:sp>
-        <p:nvSpPr>
-          <p:cNvPr id="8" name="Rectangle 7">
-            <a:extLst>
-              <a:ext uri="{FF2B5EF4-FFF2-40B4-BE49-F238E27FC236}">
-                <a16:creationId xmlns:a16="http://schemas.microsoft.com/office/drawing/2014/main" id="{3C04F9E3-4E31-C352-E4B2-AD0A7B4D6B83}"/>
-              </a:ext>
-            </a:extLst>
-          </p:cNvPr>
-          <p:cNvSpPr/>
-          <p:nvPr/>
-        </p:nvSpPr>
-        <p:spPr>
-          <a:xfrm>
-            <a:off x="8573997" y="4679804"/>
-            <a:ext cx="726141" cy="250265"/>
-          </a:xfrm>
-          <a:prstGeom prst="rect">
-            <a:avLst/>
-          </a:prstGeom>
-        </p:spPr>
-        <p:style>
-          <a:lnRef idx="2">
-            <a:schemeClr val="accent1">
-              <a:shade val="15000"/>
-            </a:schemeClr>
-          </a:lnRef>
-          <a:fillRef idx="1">
-            <a:schemeClr val="accent1"/>
-          </a:fillRef>
-          <a:effectRef idx="0">
-            <a:schemeClr val="accent1"/>
-          </a:effectRef>
-          <a:fontRef idx="minor">
-            <a:schemeClr val="lt1"/>
-          </a:fontRef>
-        </p:style>
-        <p:txBody>
-          <a:bodyPr rtlCol="0" anchor="ctr"/>
-          <a:lstStyle/>
-          <a:p>
-            <a:pPr algn="ctr"/>
-            <a:r>
-              <a:rPr lang="en-US" sz="1600" dirty="0"/>
-              <a:t>In the</a:t>
-            </a:r>
-          </a:p>
-        </p:txBody>
-      </p:sp>
-      <p:sp>
-        <p:nvSpPr>
-          <p:cNvPr id="9" name="Rectangle 8">
-            <a:extLst>
-              <a:ext uri="{FF2B5EF4-FFF2-40B4-BE49-F238E27FC236}">
-                <a16:creationId xmlns:a16="http://schemas.microsoft.com/office/drawing/2014/main" id="{9C7057E1-8716-F13F-5C0E-B8103A465217}"/>
-              </a:ext>
-            </a:extLst>
-          </p:cNvPr>
-          <p:cNvSpPr/>
-          <p:nvPr/>
-        </p:nvSpPr>
-        <p:spPr>
-          <a:xfrm>
-            <a:off x="9327936" y="4534330"/>
-            <a:ext cx="647887" cy="411628"/>
-          </a:xfrm>
-          <a:prstGeom prst="rect">
-            <a:avLst/>
-          </a:prstGeom>
-        </p:spPr>
-        <p:style>
-          <a:lnRef idx="2">
-            <a:schemeClr val="accent1">
-              <a:shade val="15000"/>
-            </a:schemeClr>
-          </a:lnRef>
-          <a:fillRef idx="1">
-            <a:schemeClr val="accent1"/>
-          </a:fillRef>
-          <a:effectRef idx="0">
-            <a:schemeClr val="accent1"/>
-          </a:effectRef>
-          <a:fontRef idx="minor">
-            <a:schemeClr val="lt1"/>
-          </a:fontRef>
-        </p:style>
-        <p:txBody>
-          <a:bodyPr rtlCol="0" anchor="ctr"/>
-          <a:lstStyle/>
-          <a:p>
-            <a:pPr algn="ctr"/>
-            <a:r>
-              <a:rPr lang="en-US" sz="1400" dirty="0"/>
-              <a:t>In the heart</a:t>
-            </a:r>
-          </a:p>
-        </p:txBody>
-      </p:sp>
-      <p:sp>
-        <p:nvSpPr>
-          <p:cNvPr id="10" name="Rectangle 9">
-            <a:extLst>
-              <a:ext uri="{FF2B5EF4-FFF2-40B4-BE49-F238E27FC236}">
-                <a16:creationId xmlns:a16="http://schemas.microsoft.com/office/drawing/2014/main" id="{6F92BDFD-B1D3-0E08-E26C-DE6544050A0C}"/>
-              </a:ext>
-            </a:extLst>
-          </p:cNvPr>
-          <p:cNvSpPr/>
-          <p:nvPr/>
-        </p:nvSpPr>
-        <p:spPr>
-          <a:xfrm>
-            <a:off x="10003621" y="4518441"/>
-            <a:ext cx="877890" cy="411628"/>
-          </a:xfrm>
-          <a:prstGeom prst="rect">
-            <a:avLst/>
-          </a:prstGeom>
-        </p:spPr>
-        <p:style>
-          <a:lnRef idx="2">
-            <a:schemeClr val="accent1">
-              <a:shade val="15000"/>
-            </a:schemeClr>
-          </a:lnRef>
-          <a:fillRef idx="1">
-            <a:schemeClr val="accent1"/>
-          </a:fillRef>
-          <a:effectRef idx="0">
-            <a:schemeClr val="accent1"/>
-          </a:effectRef>
-          <a:fontRef idx="minor">
-            <a:schemeClr val="lt1"/>
-          </a:fontRef>
-        </p:style>
-        <p:txBody>
-          <a:bodyPr rtlCol="0" anchor="ctr"/>
-          <a:lstStyle/>
-          <a:p>
-            <a:pPr algn="ctr"/>
-            <a:r>
-              <a:rPr lang="en-US" sz="1400" dirty="0"/>
-              <a:t>In the heart of</a:t>
-            </a:r>
-          </a:p>
-        </p:txBody>
-      </p:sp>
-      <p:sp>
-        <p:nvSpPr>
-          <p:cNvPr id="11" name="TextBox 10">
-            <a:extLst>
-              <a:ext uri="{FF2B5EF4-FFF2-40B4-BE49-F238E27FC236}">
-                <a16:creationId xmlns:a16="http://schemas.microsoft.com/office/drawing/2014/main" id="{9ADE42DD-CE75-973C-4F9C-E9E549765AE8}"/>
-              </a:ext>
-            </a:extLst>
-          </p:cNvPr>
-          <p:cNvSpPr txBox="1"/>
-          <p:nvPr/>
-        </p:nvSpPr>
-        <p:spPr>
-          <a:xfrm>
-            <a:off x="782605" y="2712032"/>
-            <a:ext cx="4942291" cy="3539430"/>
-          </a:xfrm>
-          <a:prstGeom prst="rect">
-            <a:avLst/>
-          </a:prstGeom>
-          <a:noFill/>
-        </p:spPr>
-        <p:txBody>
-          <a:bodyPr wrap="square" rtlCol="0">
-            <a:spAutoFit/>
-          </a:bodyPr>
-          <a:lstStyle/>
-          <a:p>
-            <a:pPr marL="285750" indent="-285750">
-              <a:buFont typeface="Arial" panose="020B0604020202020204" pitchFamily="34" charset="0"/>
-              <a:buChar char="•"/>
-            </a:pPr>
-            <a:r>
-              <a:rPr lang="en-US" sz="2800" dirty="0"/>
-              <a:t>Here we batch every 4 tokens; usually you batch hundreds at once.</a:t>
-            </a:r>
-          </a:p>
-          <a:p>
-            <a:pPr marL="285750" indent="-285750">
-              <a:buFont typeface="Arial" panose="020B0604020202020204" pitchFamily="34" charset="0"/>
-              <a:buChar char="•"/>
-            </a:pPr>
-            <a:r>
-              <a:rPr lang="en-US" sz="2800" dirty="0"/>
-              <a:t>The sliding window does not cross batch boundaries.</a:t>
-            </a:r>
-          </a:p>
-          <a:p>
-            <a:pPr marL="285750" indent="-285750">
-              <a:buFont typeface="Arial" panose="020B0604020202020204" pitchFamily="34" charset="0"/>
-              <a:buChar char="•"/>
-            </a:pPr>
-            <a:r>
-              <a:rPr lang="en-US" sz="2800" dirty="0"/>
-              <a:t>This allows parallel computation with minimal overhead.</a:t>
-            </a:r>
-          </a:p>
-        </p:txBody>
-      </p:sp>
     </p:spTree>
     <p:extLst>
       <p:ext uri="{BB962C8B-B14F-4D97-AF65-F5344CB8AC3E}">
-        <p14:creationId xmlns:p14="http://schemas.microsoft.com/office/powerpoint/2010/main" val="132023366"/>
+        <p14:creationId xmlns:p14="http://schemas.microsoft.com/office/powerpoint/2010/main" val="533775668"/>
       </p:ext>
     </p:extLst>
   </p:cSld>
@@ -7459,7 +7125,7 @@
           <p:cNvPr id="2" name="Title 1">
             <a:extLst>
               <a:ext uri="{FF2B5EF4-FFF2-40B4-BE49-F238E27FC236}">
-                <a16:creationId xmlns:a16="http://schemas.microsoft.com/office/drawing/2014/main" id="{0056034C-701D-4434-96CB-F8EADF9228ED}"/>
+                <a16:creationId xmlns:a16="http://schemas.microsoft.com/office/drawing/2014/main" id="{76428338-B99D-23B9-B2A7-AD0D449B837C}"/>
               </a:ext>
             </a:extLst>
           </p:cNvPr>
@@ -7476,8 +7142,12 @@
           <a:lstStyle/>
           <a:p>
             <a:r>
-              <a:rPr lang="en-US" dirty="0"/>
-              <a:t>Activity (10 min.)</a:t>
+              <a:rPr lang="en-US" dirty="0" err="1"/>
+              <a:t>PyTorch</a:t>
+            </a:r>
+            <a:r>
+              <a:rPr lang="en-US" dirty="0"/>
+              <a:t> Data Loader</a:t>
             </a:r>
           </a:p>
         </p:txBody>
@@ -7487,7 +7157,7 @@
           <p:cNvPr id="3" name="Content Placeholder 2">
             <a:extLst>
               <a:ext uri="{FF2B5EF4-FFF2-40B4-BE49-F238E27FC236}">
-                <a16:creationId xmlns:a16="http://schemas.microsoft.com/office/drawing/2014/main" id="{48A4BF47-6407-F4E7-1B18-85CD15C4A349}"/>
+                <a16:creationId xmlns:a16="http://schemas.microsoft.com/office/drawing/2014/main" id="{1BE08C13-506D-EEAE-70B9-E3E20CEC72C3}"/>
               </a:ext>
             </a:extLst>
           </p:cNvPr>
@@ -7505,26 +7175,343 @@
           <a:p>
             <a:r>
               <a:rPr lang="en-US" dirty="0"/>
-              <a:t>First explore sliding window</a:t>
-            </a:r>
-          </a:p>
-          <a:p>
-            <a:r>
-              <a:rPr lang="en-US" dirty="0"/>
-              <a:t>Then we will implement the Dataset and </a:t>
+              <a:t>Goal: produce an efficient data loader that takes text and turns it into a </a:t>
             </a:r>
             <a:r>
               <a:rPr lang="en-US" dirty="0" err="1"/>
-              <a:t>DataLoader</a:t>
-            </a:r>
-            <a:endParaRPr lang="en-US" dirty="0"/>
+              <a:t>PyTorch</a:t>
+            </a:r>
+            <a:r>
+              <a:rPr lang="en-US" dirty="0"/>
+              <a:t> tensor of inputs and targets.</a:t>
+            </a:r>
+          </a:p>
+        </p:txBody>
+      </p:sp>
+      <p:pic>
+        <p:nvPicPr>
+          <p:cNvPr id="5" name="Picture 4">
+            <a:extLst>
+              <a:ext uri="{FF2B5EF4-FFF2-40B4-BE49-F238E27FC236}">
+                <a16:creationId xmlns:a16="http://schemas.microsoft.com/office/drawing/2014/main" id="{5410FB21-9389-B455-2DA4-5588FC5340C8}"/>
+              </a:ext>
+            </a:extLst>
+          </p:cNvPr>
+          <p:cNvPicPr>
+            <a:picLocks noChangeAspect="1"/>
+          </p:cNvPicPr>
+          <p:nvPr/>
+        </p:nvPicPr>
+        <p:blipFill>
+          <a:blip r:embed="rId2"/>
+          <a:stretch>
+            <a:fillRect/>
+          </a:stretch>
+        </p:blipFill>
+        <p:spPr>
+          <a:xfrm>
+            <a:off x="5472539" y="2645444"/>
+            <a:ext cx="6133618" cy="3403600"/>
+          </a:xfrm>
+          <a:prstGeom prst="rect">
+            <a:avLst/>
+          </a:prstGeom>
+        </p:spPr>
+      </p:pic>
+      <p:sp>
+        <p:nvSpPr>
+          <p:cNvPr id="6" name="TextBox 5">
+            <a:extLst>
+              <a:ext uri="{FF2B5EF4-FFF2-40B4-BE49-F238E27FC236}">
+                <a16:creationId xmlns:a16="http://schemas.microsoft.com/office/drawing/2014/main" id="{DFADFC75-2FE4-5921-C83C-85E2E5418C8C}"/>
+              </a:ext>
+            </a:extLst>
+          </p:cNvPr>
+          <p:cNvSpPr txBox="1"/>
+          <p:nvPr/>
+        </p:nvSpPr>
+        <p:spPr>
+          <a:xfrm>
+            <a:off x="7531100" y="6123543"/>
+            <a:ext cx="2017475" cy="369332"/>
+          </a:xfrm>
+          <a:prstGeom prst="rect">
+            <a:avLst/>
+          </a:prstGeom>
+          <a:noFill/>
+        </p:spPr>
+        <p:txBody>
+          <a:bodyPr wrap="none" rtlCol="0">
+            <a:spAutoFit/>
+          </a:bodyPr>
+          <a:lstStyle/>
+          <a:p>
+            <a:r>
+              <a:rPr lang="en-US" dirty="0"/>
+              <a:t>(Source: Textbook)</a:t>
+            </a:r>
+          </a:p>
+        </p:txBody>
+      </p:sp>
+      <p:sp>
+        <p:nvSpPr>
+          <p:cNvPr id="7" name="Rectangle 6">
+            <a:extLst>
+              <a:ext uri="{FF2B5EF4-FFF2-40B4-BE49-F238E27FC236}">
+                <a16:creationId xmlns:a16="http://schemas.microsoft.com/office/drawing/2014/main" id="{6E400AEE-23B5-927D-4BA8-EABAD8426F1D}"/>
+              </a:ext>
+            </a:extLst>
+          </p:cNvPr>
+          <p:cNvSpPr/>
+          <p:nvPr/>
+        </p:nvSpPr>
+        <p:spPr>
+          <a:xfrm>
+            <a:off x="7962979" y="4679805"/>
+            <a:ext cx="416859" cy="250265"/>
+          </a:xfrm>
+          <a:prstGeom prst="rect">
+            <a:avLst/>
+          </a:prstGeom>
+        </p:spPr>
+        <p:style>
+          <a:lnRef idx="2">
+            <a:schemeClr val="accent1">
+              <a:shade val="15000"/>
+            </a:schemeClr>
+          </a:lnRef>
+          <a:fillRef idx="1">
+            <a:schemeClr val="accent1"/>
+          </a:fillRef>
+          <a:effectRef idx="0">
+            <a:schemeClr val="accent1"/>
+          </a:effectRef>
+          <a:fontRef idx="minor">
+            <a:schemeClr val="lt1"/>
+          </a:fontRef>
+        </p:style>
+        <p:txBody>
+          <a:bodyPr rtlCol="0" anchor="ctr"/>
+          <a:lstStyle/>
+          <a:p>
+            <a:pPr algn="ctr"/>
+            <a:r>
+              <a:rPr lang="en-US" dirty="0"/>
+              <a:t>In</a:t>
+            </a:r>
+          </a:p>
+        </p:txBody>
+      </p:sp>
+      <p:sp>
+        <p:nvSpPr>
+          <p:cNvPr id="8" name="Rectangle 7">
+            <a:extLst>
+              <a:ext uri="{FF2B5EF4-FFF2-40B4-BE49-F238E27FC236}">
+                <a16:creationId xmlns:a16="http://schemas.microsoft.com/office/drawing/2014/main" id="{3C04F9E3-4E31-C352-E4B2-AD0A7B4D6B83}"/>
+              </a:ext>
+            </a:extLst>
+          </p:cNvPr>
+          <p:cNvSpPr/>
+          <p:nvPr/>
+        </p:nvSpPr>
+        <p:spPr>
+          <a:xfrm>
+            <a:off x="8573997" y="4679804"/>
+            <a:ext cx="726141" cy="250265"/>
+          </a:xfrm>
+          <a:prstGeom prst="rect">
+            <a:avLst/>
+          </a:prstGeom>
+        </p:spPr>
+        <p:style>
+          <a:lnRef idx="2">
+            <a:schemeClr val="accent1">
+              <a:shade val="15000"/>
+            </a:schemeClr>
+          </a:lnRef>
+          <a:fillRef idx="1">
+            <a:schemeClr val="accent1"/>
+          </a:fillRef>
+          <a:effectRef idx="0">
+            <a:schemeClr val="accent1"/>
+          </a:effectRef>
+          <a:fontRef idx="minor">
+            <a:schemeClr val="lt1"/>
+          </a:fontRef>
+        </p:style>
+        <p:txBody>
+          <a:bodyPr rtlCol="0" anchor="ctr"/>
+          <a:lstStyle/>
+          <a:p>
+            <a:pPr algn="ctr"/>
+            <a:r>
+              <a:rPr lang="en-US" sz="1600" dirty="0"/>
+              <a:t>In the</a:t>
+            </a:r>
+          </a:p>
+        </p:txBody>
+      </p:sp>
+      <p:sp>
+        <p:nvSpPr>
+          <p:cNvPr id="9" name="Rectangle 8">
+            <a:extLst>
+              <a:ext uri="{FF2B5EF4-FFF2-40B4-BE49-F238E27FC236}">
+                <a16:creationId xmlns:a16="http://schemas.microsoft.com/office/drawing/2014/main" id="{9C7057E1-8716-F13F-5C0E-B8103A465217}"/>
+              </a:ext>
+            </a:extLst>
+          </p:cNvPr>
+          <p:cNvSpPr/>
+          <p:nvPr/>
+        </p:nvSpPr>
+        <p:spPr>
+          <a:xfrm>
+            <a:off x="9327936" y="4534330"/>
+            <a:ext cx="647887" cy="411628"/>
+          </a:xfrm>
+          <a:prstGeom prst="rect">
+            <a:avLst/>
+          </a:prstGeom>
+        </p:spPr>
+        <p:style>
+          <a:lnRef idx="2">
+            <a:schemeClr val="accent1">
+              <a:shade val="15000"/>
+            </a:schemeClr>
+          </a:lnRef>
+          <a:fillRef idx="1">
+            <a:schemeClr val="accent1"/>
+          </a:fillRef>
+          <a:effectRef idx="0">
+            <a:schemeClr val="accent1"/>
+          </a:effectRef>
+          <a:fontRef idx="minor">
+            <a:schemeClr val="lt1"/>
+          </a:fontRef>
+        </p:style>
+        <p:txBody>
+          <a:bodyPr rtlCol="0" anchor="ctr"/>
+          <a:lstStyle/>
+          <a:p>
+            <a:pPr algn="ctr"/>
+            <a:r>
+              <a:rPr lang="en-US" sz="1400" dirty="0"/>
+              <a:t>In the heart</a:t>
+            </a:r>
+          </a:p>
+        </p:txBody>
+      </p:sp>
+      <p:sp>
+        <p:nvSpPr>
+          <p:cNvPr id="10" name="Rectangle 9">
+            <a:extLst>
+              <a:ext uri="{FF2B5EF4-FFF2-40B4-BE49-F238E27FC236}">
+                <a16:creationId xmlns:a16="http://schemas.microsoft.com/office/drawing/2014/main" id="{6F92BDFD-B1D3-0E08-E26C-DE6544050A0C}"/>
+              </a:ext>
+            </a:extLst>
+          </p:cNvPr>
+          <p:cNvSpPr/>
+          <p:nvPr/>
+        </p:nvSpPr>
+        <p:spPr>
+          <a:xfrm>
+            <a:off x="10003621" y="4518441"/>
+            <a:ext cx="877890" cy="411628"/>
+          </a:xfrm>
+          <a:prstGeom prst="rect">
+            <a:avLst/>
+          </a:prstGeom>
+        </p:spPr>
+        <p:style>
+          <a:lnRef idx="2">
+            <a:schemeClr val="accent1">
+              <a:shade val="15000"/>
+            </a:schemeClr>
+          </a:lnRef>
+          <a:fillRef idx="1">
+            <a:schemeClr val="accent1"/>
+          </a:fillRef>
+          <a:effectRef idx="0">
+            <a:schemeClr val="accent1"/>
+          </a:effectRef>
+          <a:fontRef idx="minor">
+            <a:schemeClr val="lt1"/>
+          </a:fontRef>
+        </p:style>
+        <p:txBody>
+          <a:bodyPr rtlCol="0" anchor="ctr"/>
+          <a:lstStyle/>
+          <a:p>
+            <a:pPr algn="ctr"/>
+            <a:r>
+              <a:rPr lang="en-US" sz="1400" dirty="0"/>
+              <a:t>In the heart of</a:t>
+            </a:r>
+          </a:p>
+        </p:txBody>
+      </p:sp>
+      <p:sp>
+        <p:nvSpPr>
+          <p:cNvPr id="11" name="TextBox 10">
+            <a:extLst>
+              <a:ext uri="{FF2B5EF4-FFF2-40B4-BE49-F238E27FC236}">
+                <a16:creationId xmlns:a16="http://schemas.microsoft.com/office/drawing/2014/main" id="{9ADE42DD-CE75-973C-4F9C-E9E549765AE8}"/>
+              </a:ext>
+            </a:extLst>
+          </p:cNvPr>
+          <p:cNvSpPr txBox="1"/>
+          <p:nvPr/>
+        </p:nvSpPr>
+        <p:spPr>
+          <a:xfrm>
+            <a:off x="782605" y="2712032"/>
+            <a:ext cx="4942291" cy="3539430"/>
+          </a:xfrm>
+          <a:prstGeom prst="rect">
+            <a:avLst/>
+          </a:prstGeom>
+          <a:noFill/>
+        </p:spPr>
+        <p:txBody>
+          <a:bodyPr wrap="square" rtlCol="0">
+            <a:spAutoFit/>
+          </a:bodyPr>
+          <a:lstStyle/>
+          <a:p>
+            <a:pPr marL="285750" indent="-285750">
+              <a:buFont typeface="Arial" panose="020B0604020202020204" pitchFamily="34" charset="0"/>
+              <a:buChar char="•"/>
+            </a:pPr>
+            <a:r>
+              <a:rPr lang="en-US" sz="2800" dirty="0"/>
+              <a:t>Here we batch every 4 tokens; usually you batch hundreds at once.</a:t>
+            </a:r>
+          </a:p>
+          <a:p>
+            <a:pPr marL="285750" indent="-285750">
+              <a:buFont typeface="Arial" panose="020B0604020202020204" pitchFamily="34" charset="0"/>
+              <a:buChar char="•"/>
+            </a:pPr>
+            <a:r>
+              <a:rPr lang="en-US" sz="2800" dirty="0"/>
+              <a:t>The sliding window does not cross batch boundaries.</a:t>
+            </a:r>
+          </a:p>
+          <a:p>
+            <a:pPr marL="285750" indent="-285750">
+              <a:buFont typeface="Arial" panose="020B0604020202020204" pitchFamily="34" charset="0"/>
+              <a:buChar char="•"/>
+            </a:pPr>
+            <a:r>
+              <a:rPr lang="en-US" sz="2800" dirty="0"/>
+              <a:t>This allows parallel computation with minimal overhead.</a:t>
+            </a:r>
           </a:p>
         </p:txBody>
       </p:sp>
     </p:spTree>
     <p:extLst>
       <p:ext uri="{BB962C8B-B14F-4D97-AF65-F5344CB8AC3E}">
-        <p14:creationId xmlns:p14="http://schemas.microsoft.com/office/powerpoint/2010/main" val="2733690210"/>
+        <p14:creationId xmlns:p14="http://schemas.microsoft.com/office/powerpoint/2010/main" val="132023366"/>
       </p:ext>
     </p:extLst>
   </p:cSld>
@@ -7556,7 +7543,7 @@
           <p:cNvPr id="2" name="Title 1">
             <a:extLst>
               <a:ext uri="{FF2B5EF4-FFF2-40B4-BE49-F238E27FC236}">
-                <a16:creationId xmlns:a16="http://schemas.microsoft.com/office/drawing/2014/main" id="{85E100C7-0198-A560-8E6C-159B7239340F}"/>
+                <a16:creationId xmlns:a16="http://schemas.microsoft.com/office/drawing/2014/main" id="{0056034C-701D-4434-96CB-F8EADF9228ED}"/>
               </a:ext>
             </a:extLst>
           </p:cNvPr>
@@ -7574,25 +7561,25 @@
           <a:p>
             <a:r>
               <a:rPr lang="en-US" dirty="0"/>
-              <a:t>Embedding Vectors</a:t>
-            </a:r>
-          </a:p>
-        </p:txBody>
-      </p:sp>
-      <p:sp>
-        <p:nvSpPr>
-          <p:cNvPr id="3" name="Text Placeholder 2">
-            <a:extLst>
-              <a:ext uri="{FF2B5EF4-FFF2-40B4-BE49-F238E27FC236}">
-                <a16:creationId xmlns:a16="http://schemas.microsoft.com/office/drawing/2014/main" id="{3B9D2EFC-11D3-693D-BE5F-E2A42B3E550F}"/>
-              </a:ext>
-            </a:extLst>
-          </p:cNvPr>
-          <p:cNvSpPr>
-            <a:spLocks noGrp="1"/>
-          </p:cNvSpPr>
-          <p:nvPr>
-            <p:ph type="body" idx="1"/>
+              <a:t>Activity (10 min.)</a:t>
+            </a:r>
+          </a:p>
+        </p:txBody>
+      </p:sp>
+      <p:sp>
+        <p:nvSpPr>
+          <p:cNvPr id="3" name="Content Placeholder 2">
+            <a:extLst>
+              <a:ext uri="{FF2B5EF4-FFF2-40B4-BE49-F238E27FC236}">
+                <a16:creationId xmlns:a16="http://schemas.microsoft.com/office/drawing/2014/main" id="{48A4BF47-6407-F4E7-1B18-85CD15C4A349}"/>
+              </a:ext>
+            </a:extLst>
+          </p:cNvPr>
+          <p:cNvSpPr>
+            <a:spLocks noGrp="1"/>
+          </p:cNvSpPr>
+          <p:nvPr>
+            <p:ph idx="1"/>
           </p:nvPr>
         </p:nvSpPr>
         <p:spPr/>
@@ -7600,14 +7587,28 @@
           <a:bodyPr/>
           <a:lstStyle/>
           <a:p>
-            <a:endParaRPr lang="en-US"/>
+            <a:r>
+              <a:rPr lang="en-US" dirty="0"/>
+              <a:t>First explore sliding window</a:t>
+            </a:r>
+          </a:p>
+          <a:p>
+            <a:r>
+              <a:rPr lang="en-US" dirty="0"/>
+              <a:t>Then we will implement the Dataset and </a:t>
+            </a:r>
+            <a:r>
+              <a:rPr lang="en-US" dirty="0" err="1"/>
+              <a:t>DataLoader</a:t>
+            </a:r>
+            <a:endParaRPr lang="en-US" dirty="0"/>
           </a:p>
         </p:txBody>
       </p:sp>
     </p:spTree>
     <p:extLst>
       <p:ext uri="{BB962C8B-B14F-4D97-AF65-F5344CB8AC3E}">
-        <p14:creationId xmlns:p14="http://schemas.microsoft.com/office/powerpoint/2010/main" val="3032906179"/>
+        <p14:creationId xmlns:p14="http://schemas.microsoft.com/office/powerpoint/2010/main" val="2733690210"/>
       </p:ext>
     </p:extLst>
   </p:cSld>
@@ -7639,7 +7640,7 @@
           <p:cNvPr id="2" name="Title 1">
             <a:extLst>
               <a:ext uri="{FF2B5EF4-FFF2-40B4-BE49-F238E27FC236}">
-                <a16:creationId xmlns:a16="http://schemas.microsoft.com/office/drawing/2014/main" id="{2F398605-4559-A4E5-D2CE-739B6B21E083}"/>
+                <a16:creationId xmlns:a16="http://schemas.microsoft.com/office/drawing/2014/main" id="{85E100C7-0198-A560-8E6C-159B7239340F}"/>
               </a:ext>
             </a:extLst>
           </p:cNvPr>
@@ -7657,25 +7658,25 @@
           <a:p>
             <a:r>
               <a:rPr lang="en-US" dirty="0"/>
-              <a:t>Embeddings as a Map from ID to Vector</a:t>
-            </a:r>
-          </a:p>
-        </p:txBody>
-      </p:sp>
-      <p:sp>
-        <p:nvSpPr>
-          <p:cNvPr id="3" name="Content Placeholder 2">
-            <a:extLst>
-              <a:ext uri="{FF2B5EF4-FFF2-40B4-BE49-F238E27FC236}">
-                <a16:creationId xmlns:a16="http://schemas.microsoft.com/office/drawing/2014/main" id="{F22CC5D7-9F5D-A25E-FA30-4DC1AC4A2FBD}"/>
-              </a:ext>
-            </a:extLst>
-          </p:cNvPr>
-          <p:cNvSpPr>
-            <a:spLocks noGrp="1"/>
-          </p:cNvSpPr>
-          <p:nvPr>
-            <p:ph idx="1"/>
+              <a:t>Embedding Vectors</a:t>
+            </a:r>
+          </a:p>
+        </p:txBody>
+      </p:sp>
+      <p:sp>
+        <p:nvSpPr>
+          <p:cNvPr id="3" name="Text Placeholder 2">
+            <a:extLst>
+              <a:ext uri="{FF2B5EF4-FFF2-40B4-BE49-F238E27FC236}">
+                <a16:creationId xmlns:a16="http://schemas.microsoft.com/office/drawing/2014/main" id="{3B9D2EFC-11D3-693D-BE5F-E2A42B3E550F}"/>
+              </a:ext>
+            </a:extLst>
+          </p:cNvPr>
+          <p:cNvSpPr>
+            <a:spLocks noGrp="1"/>
+          </p:cNvSpPr>
+          <p:nvPr>
+            <p:ph type="body" idx="1"/>
           </p:nvPr>
         </p:nvSpPr>
         <p:spPr/>
@@ -7683,53 +7684,14 @@
           <a:bodyPr/>
           <a:lstStyle/>
           <a:p>
-            <a:r>
-              <a:rPr lang="en-US" dirty="0"/>
-              <a:t>Each token ID corresponds with an embedding vector.</a:t>
-            </a:r>
-          </a:p>
-          <a:p>
-            <a:r>
-              <a:rPr lang="en-US" dirty="0"/>
-              <a:t>As discussed previously, vectors embed semantic information about tokens’ meaning.</a:t>
-            </a:r>
-          </a:p>
-          <a:p>
-            <a:r>
-              <a:rPr lang="en-US" dirty="0"/>
-              <a:t>Today, we will work with randomized embeddings, focusing only on the lookup portion.</a:t>
-            </a:r>
-          </a:p>
-          <a:p>
-            <a:pPr lvl="1"/>
-            <a:r>
-              <a:rPr lang="en-US" dirty="0"/>
-              <a:t>We will use </a:t>
-            </a:r>
-            <a:r>
-              <a:rPr lang="en-US" dirty="0" err="1">
-                <a:latin typeface="Courier New" panose="02070309020205020404" pitchFamily="49" charset="0"/>
-                <a:cs typeface="Courier New" panose="02070309020205020404" pitchFamily="49" charset="0"/>
-              </a:rPr>
-              <a:t>torch.nn.Embedding</a:t>
-            </a:r>
-            <a:r>
-              <a:rPr lang="en-US" dirty="0"/>
-              <a:t>.</a:t>
-            </a:r>
-          </a:p>
-          <a:p>
-            <a:r>
-              <a:rPr lang="en-US" dirty="0"/>
-              <a:t>We will train these embeddings at the same time as the main language model in Pretraining (Dongyu – 4/7).</a:t>
-            </a:r>
+            <a:endParaRPr lang="en-US"/>
           </a:p>
         </p:txBody>
       </p:sp>
     </p:spTree>
     <p:extLst>
       <p:ext uri="{BB962C8B-B14F-4D97-AF65-F5344CB8AC3E}">
-        <p14:creationId xmlns:p14="http://schemas.microsoft.com/office/powerpoint/2010/main" val="1460286337"/>
+        <p14:creationId xmlns:p14="http://schemas.microsoft.com/office/powerpoint/2010/main" val="3032906179"/>
       </p:ext>
     </p:extLst>
   </p:cSld>
@@ -7823,6 +7785,128 @@
 </file>
 
 <file path=ppt/slides/slide30.xml><?xml version="1.0" encoding="utf-8"?>
+<p:sld xmlns:a="http://schemas.openxmlformats.org/drawingml/2006/main" xmlns:r="http://schemas.openxmlformats.org/officeDocument/2006/relationships" xmlns:p="http://schemas.openxmlformats.org/presentationml/2006/main">
+  <p:cSld>
+    <p:spTree>
+      <p:nvGrpSpPr>
+        <p:cNvPr id="1" name=""/>
+        <p:cNvGrpSpPr/>
+        <p:nvPr/>
+      </p:nvGrpSpPr>
+      <p:grpSpPr>
+        <a:xfrm>
+          <a:off x="0" y="0"/>
+          <a:ext cx="0" cy="0"/>
+          <a:chOff x="0" y="0"/>
+          <a:chExt cx="0" cy="0"/>
+        </a:xfrm>
+      </p:grpSpPr>
+      <p:sp>
+        <p:nvSpPr>
+          <p:cNvPr id="2" name="Title 1">
+            <a:extLst>
+              <a:ext uri="{FF2B5EF4-FFF2-40B4-BE49-F238E27FC236}">
+                <a16:creationId xmlns:a16="http://schemas.microsoft.com/office/drawing/2014/main" id="{2F398605-4559-A4E5-D2CE-739B6B21E083}"/>
+              </a:ext>
+            </a:extLst>
+          </p:cNvPr>
+          <p:cNvSpPr>
+            <a:spLocks noGrp="1"/>
+          </p:cNvSpPr>
+          <p:nvPr>
+            <p:ph type="title"/>
+          </p:nvPr>
+        </p:nvSpPr>
+        <p:spPr/>
+        <p:txBody>
+          <a:bodyPr/>
+          <a:lstStyle/>
+          <a:p>
+            <a:r>
+              <a:rPr lang="en-US" dirty="0"/>
+              <a:t>Embeddings as a Map from ID to Vector</a:t>
+            </a:r>
+          </a:p>
+        </p:txBody>
+      </p:sp>
+      <p:sp>
+        <p:nvSpPr>
+          <p:cNvPr id="3" name="Content Placeholder 2">
+            <a:extLst>
+              <a:ext uri="{FF2B5EF4-FFF2-40B4-BE49-F238E27FC236}">
+                <a16:creationId xmlns:a16="http://schemas.microsoft.com/office/drawing/2014/main" id="{F22CC5D7-9F5D-A25E-FA30-4DC1AC4A2FBD}"/>
+              </a:ext>
+            </a:extLst>
+          </p:cNvPr>
+          <p:cNvSpPr>
+            <a:spLocks noGrp="1"/>
+          </p:cNvSpPr>
+          <p:nvPr>
+            <p:ph idx="1"/>
+          </p:nvPr>
+        </p:nvSpPr>
+        <p:spPr/>
+        <p:txBody>
+          <a:bodyPr/>
+          <a:lstStyle/>
+          <a:p>
+            <a:r>
+              <a:rPr lang="en-US" dirty="0"/>
+              <a:t>Each token ID corresponds with an embedding vector.</a:t>
+            </a:r>
+          </a:p>
+          <a:p>
+            <a:r>
+              <a:rPr lang="en-US" dirty="0"/>
+              <a:t>As discussed previously, vectors embed semantic information about tokens’ meaning.</a:t>
+            </a:r>
+          </a:p>
+          <a:p>
+            <a:r>
+              <a:rPr lang="en-US" dirty="0"/>
+              <a:t>Today, we will work with randomized embeddings, focusing only on the lookup portion.</a:t>
+            </a:r>
+          </a:p>
+          <a:p>
+            <a:pPr lvl="1"/>
+            <a:r>
+              <a:rPr lang="en-US" dirty="0"/>
+              <a:t>We will use </a:t>
+            </a:r>
+            <a:r>
+              <a:rPr lang="en-US" dirty="0" err="1">
+                <a:latin typeface="Courier New" panose="02070309020205020404" pitchFamily="49" charset="0"/>
+                <a:cs typeface="Courier New" panose="02070309020205020404" pitchFamily="49" charset="0"/>
+              </a:rPr>
+              <a:t>torch.nn.Embedding</a:t>
+            </a:r>
+            <a:r>
+              <a:rPr lang="en-US" dirty="0"/>
+              <a:t>.</a:t>
+            </a:r>
+          </a:p>
+          <a:p>
+            <a:r>
+              <a:rPr lang="en-US" dirty="0"/>
+              <a:t>We will train these embeddings at the same time as the main language model in Pretraining (Dongyu – 4/7).</a:t>
+            </a:r>
+          </a:p>
+        </p:txBody>
+      </p:sp>
+    </p:spTree>
+    <p:extLst>
+      <p:ext uri="{BB962C8B-B14F-4D97-AF65-F5344CB8AC3E}">
+        <p14:creationId xmlns:p14="http://schemas.microsoft.com/office/powerpoint/2010/main" val="1460286337"/>
+      </p:ext>
+    </p:extLst>
+  </p:cSld>
+  <p:clrMapOvr>
+    <a:masterClrMapping/>
+  </p:clrMapOvr>
+</p:sld>
+</file>
+
+<file path=ppt/slides/slide31.xml><?xml version="1.0" encoding="utf-8"?>
 <p:sld xmlns:a="http://schemas.openxmlformats.org/drawingml/2006/main" xmlns:r="http://schemas.openxmlformats.org/officeDocument/2006/relationships" xmlns:p="http://schemas.openxmlformats.org/presentationml/2006/main">
   <p:cSld>
     <p:spTree>
@@ -8445,7 +8529,7 @@
 </p:sld>
 </file>
 
-<file path=ppt/slides/slide31.xml><?xml version="1.0" encoding="utf-8"?>
+<file path=ppt/slides/slide32.xml><?xml version="1.0" encoding="utf-8"?>
 <p:sld xmlns:a="http://schemas.openxmlformats.org/drawingml/2006/main" xmlns:r="http://schemas.openxmlformats.org/officeDocument/2006/relationships" xmlns:p="http://schemas.openxmlformats.org/presentationml/2006/main">
   <p:cSld>
     <p:spTree>
@@ -8533,7 +8617,7 @@
 </p:sld>
 </file>
 
-<file path=ppt/slides/slide32.xml><?xml version="1.0" encoding="utf-8"?>
+<file path=ppt/slides/slide33.xml><?xml version="1.0" encoding="utf-8"?>
 <p:sld xmlns:a="http://schemas.openxmlformats.org/drawingml/2006/main" xmlns:r="http://schemas.openxmlformats.org/officeDocument/2006/relationships" xmlns:p="http://schemas.openxmlformats.org/presentationml/2006/main">
   <p:cSld>
     <p:spTree>
@@ -8735,7 +8819,7 @@
 </p:sld>
 </file>
 
-<file path=ppt/slides/slide33.xml><?xml version="1.0" encoding="utf-8"?>
+<file path=ppt/slides/slide34.xml><?xml version="1.0" encoding="utf-8"?>
 <p:sld xmlns:a="http://schemas.openxmlformats.org/drawingml/2006/main" xmlns:r="http://schemas.openxmlformats.org/officeDocument/2006/relationships" xmlns:p="http://schemas.openxmlformats.org/presentationml/2006/main">
   <p:cSld>
     <p:spTree>
@@ -8923,7 +9007,7 @@
 </p:sld>
 </file>
 
-<file path=ppt/slides/slide34.xml><?xml version="1.0" encoding="utf-8"?>
+<file path=ppt/slides/slide35.xml><?xml version="1.0" encoding="utf-8"?>
 <p:sld xmlns:a="http://schemas.openxmlformats.org/drawingml/2006/main" xmlns:r="http://schemas.openxmlformats.org/officeDocument/2006/relationships" xmlns:p="http://schemas.openxmlformats.org/presentationml/2006/main">
   <p:cSld>
     <p:spTree>

</xml_diff>